<commit_message>
Add whole-experience diagram slide to portfolio decks
Rebuild the complete (188 slides), combined (144), and core (49) decks with the
end-to-end experience diagram.

Co-Authored-By: Claude Haiku 5.5 <noreply@anthropic.com>
</commit_message>
<xml_diff>
--- a/Portfolio-Core.pptx
+++ b/Portfolio-Core.pptx
@@ -55,6 +55,7 @@
     <p:sldId id="460" r:id="rId52"/>
     <p:sldId id="461" r:id="rId53"/>
     <p:sldId id="462" r:id="rId54"/>
+    <p:sldId id="463" r:id="rId55"/>
     <p:sldId id="435" r:id="rId43"/>
   </p:sldIdLst>
   <p:sldSz cx="13004800" cy="9753600"/>
@@ -26603,7 +26604,7 @@
     <p:bg>
       <p:bgPr>
         <a:solidFill>
-          <a:srgbClr val="C45A35"/>
+          <a:srgbClr val="FFFFFF"/>
         </a:solidFill>
       </p:bgPr>
     </p:bg>
@@ -26622,8 +26623,8 @@
         </p:nvSpPr>
         <p:spPr>
           <a:xfrm>
-            <a:off x="978408" y="978408"/>
-            <a:ext cx="10515600" cy="1097280"/>
+            <a:off x="457200" y="393192"/>
+            <a:ext cx="10424160" cy="274320"/>
           </a:xfrm>
           <a:prstGeom prst="rect">
             <a:avLst/>
@@ -26639,30 +26640,69 @@
               <a:buNone/>
             </a:pPr>
             <a:r>
-              <a:rPr lang="en-US" sz="5700" dirty="0">
-                <a:solidFill>
-                  <a:srgbClr val="FFFFFF"/>
+              <a:rPr lang="en-US" sz="1422" dirty="0">
+                <a:solidFill>
+                  <a:srgbClr val="1F1F1F"/>
+                </a:solidFill>
+                <a:latin typeface="Helvetica Neue" pitchFamily="34" charset="0"/>
+                <a:ea typeface="Helvetica Neue" pitchFamily="34" charset="-122"/>
+                <a:cs typeface="Helvetica Neue" pitchFamily="34" charset="-120"/>
+              </a:rPr>
+              <a:t>06 · Agent experience   Meridian Navigator</a:t>
+            </a:r>
+            <a:endParaRPr lang="en-US" sz="1422" dirty="0"/>
+          </a:p>
+        </p:txBody>
+      </p:sp>
+      <p:sp>
+        <p:nvSpPr>
+          <p:cNvPr id="3" name="Text 1"/>
+          <p:cNvSpPr txBox="1"/>
+          <p:nvPr/>
+        </p:nvSpPr>
+        <p:spPr>
+          <a:xfrm>
+            <a:off x="457200" y="914400"/>
+            <a:ext cx="12070080" cy="594360"/>
+          </a:xfrm>
+          <a:prstGeom prst="rect">
+            <a:avLst/>
+          </a:prstGeom>
+          <a:noFill/>
+          <a:ln/>
+        </p:spPr>
+        <p:txBody>
+          <a:bodyPr wrap="square" lIns="0" tIns="0" rIns="0" bIns="0" rtlCol="0" anchor="t"/>
+          <a:lstStyle/>
+          <a:p>
+            <a:pPr indent="0" marL="0">
+              <a:buNone/>
+            </a:pPr>
+            <a:r>
+              <a:rPr lang="en-US" sz="3200" dirty="0">
+                <a:solidFill>
+                  <a:srgbClr val="1F1F1F"/>
                 </a:solidFill>
                 <a:latin typeface="Helvetica Neue Light" pitchFamily="34" charset="0"/>
                 <a:ea typeface="Helvetica Neue Light" pitchFamily="34" charset="-122"/>
                 <a:cs typeface="Helvetica Neue Light" pitchFamily="34" charset="-120"/>
               </a:rPr>
-              <a:t>Build and test</a:t>
-            </a:r>
-            <a:endParaRPr lang="en-US" sz="5700" dirty="0"/>
-          </a:p>
-        </p:txBody>
-      </p:sp>
-      <p:sp>
-        <p:nvSpPr>
-          <p:cNvPr id="3" name="Text 1"/>
-          <p:cNvSpPr txBox="1"/>
-          <p:nvPr/>
-        </p:nvSpPr>
-        <p:spPr>
-          <a:xfrm>
-            <a:off x="1078992" y="2286000"/>
-            <a:ext cx="9601200" cy="822960"/>
+              <a:t>The whole experience, end to end</a:t>
+            </a:r>
+            <a:endParaRPr lang="en-US" sz="3200" dirty="0"/>
+          </a:p>
+        </p:txBody>
+      </p:sp>
+      <p:sp>
+        <p:nvSpPr>
+          <p:cNvPr id="4" name="Text 2"/>
+          <p:cNvSpPr txBox="1"/>
+          <p:nvPr/>
+        </p:nvSpPr>
+        <p:spPr>
+          <a:xfrm>
+            <a:off x="457200" y="1554480"/>
+            <a:ext cx="12070080" cy="365760"/>
           </a:xfrm>
           <a:prstGeom prst="rect">
             <a:avLst/>
@@ -26678,23 +26718,110 @@
               <a:buNone/>
             </a:pPr>
             <a:r>
-              <a:rPr lang="en-US" sz="1900" dirty="0">
-                <a:solidFill>
-                  <a:srgbClr val="FFE9DF"/>
+              <a:rPr lang="en-US" sz="1636" dirty="0">
+                <a:solidFill>
+                  <a:srgbClr val="595959"/>
                 </a:solidFill>
                 <a:latin typeface="Helvetica Neue Light" pitchFamily="34" charset="0"/>
                 <a:ea typeface="Helvetica Neue Light" pitchFamily="34" charset="-122"/>
                 <a:cs typeface="Helvetica Neue Light" pitchFamily="34" charset="-120"/>
               </a:rPr>
-              <a:t>How the AI behaves, how it is built, and how we will check it.</a:t>
-            </a:r>
-            <a:endParaRPr lang="en-US" sz="1900" dirty="0"/>
+              <a:t>Entry, the five tabs, monitoring, Adapt, the trade flow, the learning loop, and the states. Proposal, mock data.</a:t>
+            </a:r>
+            <a:endParaRPr lang="en-US" sz="1636" dirty="0"/>
           </a:p>
         </p:txBody>
       </p:sp>
       <p:pic>
         <p:nvPicPr>
-          <p:cNvPr id="4" name="Image 0" descr="/tmp/meridian-deck/img/band-footer.png">    </p:cNvPr>
+          <p:cNvPr id="5" name="Image 0" descr="/tmp/meridian-deck/img/band-footer.png">    </p:cNvPr>
+          <p:cNvPicPr>
+            <a:picLocks noChangeAspect="1"/>
+          </p:cNvPicPr>
+          <p:nvPr/>
+        </p:nvPicPr>
+        <p:blipFill>
+          <a:blip r:embed="rId2"/>
+          <a:stretch>
+            <a:fillRect/>
+          </a:stretch>
+        </p:blipFill>
+        <p:spPr>
+          <a:xfrm>
+            <a:off x="0" y="9281160"/>
+            <a:ext cx="13004597" cy="466344"/>
+          </a:xfrm>
+          <a:prstGeom prst="rect">
+            <a:avLst/>
+          </a:prstGeom>
+        </p:spPr>
+      </p:pic>
+      <p:pic>
+        <p:nvPicPr>
+          <p:cNvPr id="6" name="Image 1" descr="/tmp/meridian-deck/img/full-experience.png">    </p:cNvPr>
+          <p:cNvPicPr>
+            <a:picLocks noChangeAspect="1"/>
+          </p:cNvPicPr>
+          <p:nvPr/>
+        </p:nvPicPr>
+        <p:blipFill>
+          <a:blip r:embed="rId3"/>
+          <a:stretch>
+            <a:fillRect/>
+          </a:stretch>
+        </p:blipFill>
+        <p:spPr>
+          <a:xfrm>
+            <a:off x="457200" y="2194560"/>
+            <a:ext cx="12070080" cy="5956663"/>
+          </a:xfrm>
+          <a:prstGeom prst="rect">
+            <a:avLst/>
+          </a:prstGeom>
+        </p:spPr>
+      </p:pic>
+      <p:sp>
+        <p:nvSpPr>
+          <p:cNvPr id="7" name="Text 3"/>
+          <p:cNvSpPr txBox="1"/>
+          <p:nvPr/>
+        </p:nvSpPr>
+        <p:spPr>
+          <a:xfrm>
+            <a:off x="457200" y="8425543"/>
+            <a:ext cx="12070080" cy="457200"/>
+          </a:xfrm>
+          <a:prstGeom prst="rect">
+            <a:avLst/>
+          </a:prstGeom>
+          <a:noFill/>
+          <a:ln/>
+        </p:spPr>
+        <p:txBody>
+          <a:bodyPr wrap="square" lIns="0" tIns="0" rIns="0" bIns="0" rtlCol="0" anchor="t"/>
+          <a:lstStyle/>
+          <a:p>
+            <a:pPr indent="0" marL="0">
+              <a:buNone/>
+            </a:pPr>
+            <a:r>
+              <a:rPr lang="en-US" sz="1500" dirty="0">
+                <a:solidFill>
+                  <a:srgbClr val="595959"/>
+                </a:solidFill>
+                <a:latin typeface="Helvetica Neue Light" pitchFamily="34" charset="0"/>
+                <a:ea typeface="Helvetica Neue Light" pitchFamily="34" charset="-122"/>
+                <a:cs typeface="Helvetica Neue Light" pitchFamily="34" charset="-120"/>
+              </a:rPr>
+              <a:t>Nothing trades unless the user approves, or has set Act within limits. Learned rules are visible and reversible.</a:t>
+            </a:r>
+            <a:endParaRPr lang="en-US" sz="1500" dirty="0"/>
+          </a:p>
+        </p:txBody>
+      </p:sp>
+      <p:pic>
+        <p:nvPicPr>
+          <p:cNvPr id="8" name="Image 2" descr="/tmp/meridian-deck/img/band-footer.png">    </p:cNvPr>
           <p:cNvPicPr>
             <a:picLocks noChangeAspect="1"/>
           </p:cNvPicPr>
@@ -26730,7 +26857,7 @@
     <p:bg>
       <p:bgPr>
         <a:solidFill>
-          <a:srgbClr val="FFFFFF"/>
+          <a:srgbClr val="C45A35"/>
         </a:solidFill>
       </p:bgPr>
     </p:bg>
@@ -26749,8 +26876,8 @@
         </p:nvSpPr>
         <p:spPr>
           <a:xfrm>
-            <a:off x="457200" y="393192"/>
-            <a:ext cx="10424160" cy="274320"/>
+            <a:off x="978408" y="978408"/>
+            <a:ext cx="10515600" cy="1097280"/>
           </a:xfrm>
           <a:prstGeom prst="rect">
             <a:avLst/>
@@ -26766,376 +26893,62 @@
               <a:buNone/>
             </a:pPr>
             <a:r>
-              <a:rPr lang="en-US" sz="1422" dirty="0">
-                <a:solidFill>
-                  <a:srgbClr val="1F1F1F"/>
-                </a:solidFill>
-                <a:latin typeface="Helvetica Neue" pitchFamily="34" charset="0"/>
-                <a:ea typeface="Helvetica Neue" pitchFamily="34" charset="-122"/>
-                <a:cs typeface="Helvetica Neue" pitchFamily="34" charset="-120"/>
-              </a:rPr>
-              <a:t>07 · Methodology   Meridian Navigator</a:t>
-            </a:r>
-            <a:endParaRPr lang="en-US" sz="1422" dirty="0"/>
-          </a:p>
-        </p:txBody>
-      </p:sp>
-      <p:sp>
-        <p:nvSpPr>
-          <p:cNvPr id="3" name="Text 1"/>
-          <p:cNvSpPr txBox="1"/>
-          <p:nvPr/>
-        </p:nvSpPr>
-        <p:spPr>
-          <a:xfrm>
-            <a:off x="457200" y="914400"/>
-            <a:ext cx="12070080" cy="594360"/>
-          </a:xfrm>
-          <a:prstGeom prst="rect">
-            <a:avLst/>
-          </a:prstGeom>
-          <a:noFill/>
-          <a:ln/>
-        </p:spPr>
-        <p:txBody>
-          <a:bodyPr wrap="square" lIns="0" tIns="0" rIns="0" bIns="0" rtlCol="0" anchor="t"/>
-          <a:lstStyle/>
-          <a:p>
-            <a:pPr indent="0" marL="0">
-              <a:buNone/>
-            </a:pPr>
-            <a:r>
-              <a:rPr lang="en-US" sz="3200" dirty="0">
-                <a:solidFill>
-                  <a:srgbClr val="1F1F1F"/>
+              <a:rPr lang="en-US" sz="5700" dirty="0">
+                <a:solidFill>
+                  <a:srgbClr val="FFFFFF"/>
                 </a:solidFill>
                 <a:latin typeface="Helvetica Neue Light" pitchFamily="34" charset="0"/>
                 <a:ea typeface="Helvetica Neue Light" pitchFamily="34" charset="-122"/>
                 <a:cs typeface="Helvetica Neue Light" pitchFamily="34" charset="-120"/>
               </a:rPr>
-              <a:t>How the AI behaves, and how we will test it</a:t>
-            </a:r>
-            <a:endParaRPr lang="en-US" sz="3200" dirty="0"/>
+              <a:t>Build and test</a:t>
+            </a:r>
+            <a:endParaRPr lang="en-US" sz="5700" dirty="0"/>
+          </a:p>
+        </p:txBody>
+      </p:sp>
+      <p:sp>
+        <p:nvSpPr>
+          <p:cNvPr id="3" name="Text 1"/>
+          <p:cNvSpPr txBox="1"/>
+          <p:nvPr/>
+        </p:nvSpPr>
+        <p:spPr>
+          <a:xfrm>
+            <a:off x="1078992" y="2286000"/>
+            <a:ext cx="9601200" cy="822960"/>
+          </a:xfrm>
+          <a:prstGeom prst="rect">
+            <a:avLst/>
+          </a:prstGeom>
+          <a:noFill/>
+          <a:ln/>
+        </p:spPr>
+        <p:txBody>
+          <a:bodyPr wrap="square" lIns="0" tIns="0" rIns="0" bIns="0" rtlCol="0" anchor="t"/>
+          <a:lstStyle/>
+          <a:p>
+            <a:pPr indent="0" marL="0">
+              <a:buNone/>
+            </a:pPr>
+            <a:r>
+              <a:rPr lang="en-US" sz="1900" dirty="0">
+                <a:solidFill>
+                  <a:srgbClr val="FFE9DF"/>
+                </a:solidFill>
+                <a:latin typeface="Helvetica Neue Light" pitchFamily="34" charset="0"/>
+                <a:ea typeface="Helvetica Neue Light" pitchFamily="34" charset="-122"/>
+                <a:cs typeface="Helvetica Neue Light" pitchFamily="34" charset="-120"/>
+              </a:rPr>
+              <a:t>How the AI behaves, how it is built, and how we will check it.</a:t>
+            </a:r>
+            <a:endParaRPr lang="en-US" sz="1900" dirty="0"/>
           </a:p>
         </p:txBody>
       </p:sp>
       <p:pic>
         <p:nvPicPr>
           <p:cNvPr id="4" name="Image 0" descr="/tmp/meridian-deck/img/band-footer.png">    </p:cNvPr>
-          <p:cNvPicPr>
-            <a:picLocks noChangeAspect="1"/>
-          </p:cNvPicPr>
-          <p:nvPr/>
-        </p:nvPicPr>
-        <p:blipFill>
-          <a:blip r:embed="rId2"/>
-          <a:stretch>
-            <a:fillRect/>
-          </a:stretch>
-        </p:blipFill>
-        <p:spPr>
-          <a:xfrm>
-            <a:off x="0" y="9281160"/>
-            <a:ext cx="13004597" cy="466344"/>
-          </a:xfrm>
-          <a:prstGeom prst="rect">
-            <a:avLst/>
-          </a:prstGeom>
-        </p:spPr>
-      </p:pic>
-      <p:sp>
-        <p:nvSpPr>
-          <p:cNvPr id="5" name="Text 2"/>
-          <p:cNvSpPr txBox="1"/>
-          <p:nvPr/>
-        </p:nvSpPr>
-        <p:spPr>
-          <a:xfrm>
-            <a:off x="457200" y="2468880"/>
-            <a:ext cx="5669280" cy="274320"/>
-          </a:xfrm>
-          <a:prstGeom prst="rect">
-            <a:avLst/>
-          </a:prstGeom>
-          <a:noFill/>
-          <a:ln/>
-        </p:spPr>
-        <p:txBody>
-          <a:bodyPr wrap="square" lIns="0" tIns="0" rIns="0" bIns="0" rtlCol="0" anchor="t"/>
-          <a:lstStyle/>
-          <a:p>
-            <a:pPr indent="0" marL="0">
-              <a:buNone/>
-            </a:pPr>
-            <a:r>
-              <a:rPr lang="en-US" sz="1280" spc="100" kern="0" dirty="0">
-                <a:solidFill>
-                  <a:srgbClr val="5B3F96"/>
-                </a:solidFill>
-                <a:latin typeface="Helvetica Neue" pitchFamily="34" charset="0"/>
-                <a:ea typeface="Helvetica Neue" pitchFamily="34" charset="-122"/>
-                <a:cs typeface="Helvetica Neue" pitchFamily="34" charset="-120"/>
-              </a:rPr>
-              <a:t>AI BEHAVIOR · DESIGNED, MOCK DATA</a:t>
-            </a:r>
-            <a:endParaRPr lang="en-US" sz="1280" dirty="0"/>
-          </a:p>
-        </p:txBody>
-      </p:sp>
-      <p:sp>
-        <p:nvSpPr>
-          <p:cNvPr id="6" name="Text 3"/>
-          <p:cNvSpPr txBox="1"/>
-          <p:nvPr/>
-        </p:nvSpPr>
-        <p:spPr>
-          <a:xfrm>
-            <a:off x="457200" y="2926080"/>
-            <a:ext cx="5669280" cy="4114800"/>
-          </a:xfrm>
-          <a:prstGeom prst="rect">
-            <a:avLst/>
-          </a:prstGeom>
-          <a:noFill/>
-          <a:ln/>
-        </p:spPr>
-        <p:txBody>
-          <a:bodyPr wrap="square" lIns="0" tIns="0" rIns="0" bIns="0" rtlCol="0" anchor="t"/>
-          <a:lstStyle/>
-          <a:p>
-            <a:pPr marL="203200" indent="-203200">
-              <a:spcAft>
-                <a:spcPts val="600"/>
-              </a:spcAft>
-              <a:buSzPct val="100000"/>
-              <a:buChar char="•"/>
-            </a:pPr>
-            <a:r>
-              <a:rPr lang="en-US" sz="1800" dirty="0">
-                <a:solidFill>
-                  <a:srgbClr val="1F1F1F"/>
-                </a:solidFill>
-                <a:latin typeface="Helvetica Neue Light" pitchFamily="34" charset="0"/>
-                <a:ea typeface="Helvetica Neue Light" pitchFamily="34" charset="-122"/>
-                <a:cs typeface="Helvetica Neue Light" pitchFamily="34" charset="-120"/>
-              </a:rPr>
-              <a:t>Insight: sentiment summaries, with the screen as the source</a:t>
-            </a:r>
-            <a:endParaRPr lang="en-US" sz="1800" dirty="0"/>
-          </a:p>
-          <a:p>
-            <a:pPr marL="203200" indent="-203200">
-              <a:spcAft>
-                <a:spcPts val="600"/>
-              </a:spcAft>
-              <a:buSzPct val="100000"/>
-              <a:buChar char="•"/>
-            </a:pPr>
-            <a:r>
-              <a:rPr lang="en-US" sz="1800" dirty="0">
-                <a:solidFill>
-                  <a:srgbClr val="1F1F1F"/>
-                </a:solidFill>
-                <a:latin typeface="Helvetica Neue Light" pitchFamily="34" charset="0"/>
-                <a:ea typeface="Helvetica Neue Light" pitchFamily="34" charset="-122"/>
-                <a:cs typeface="Helvetica Neue Light" pitchFamily="34" charset="-120"/>
-              </a:rPr>
-              <a:t>Prospect: opportunity cards with upside and downside</a:t>
-            </a:r>
-            <a:endParaRPr lang="en-US" sz="1800" dirty="0"/>
-          </a:p>
-          <a:p>
-            <a:pPr marL="203200" indent="-203200">
-              <a:spcAft>
-                <a:spcPts val="600"/>
-              </a:spcAft>
-              <a:buSzPct val="100000"/>
-              <a:buChar char="•"/>
-            </a:pPr>
-            <a:r>
-              <a:rPr lang="en-US" sz="1800" dirty="0">
-                <a:solidFill>
-                  <a:srgbClr val="1F1F1F"/>
-                </a:solidFill>
-                <a:latin typeface="Helvetica Neue Light" pitchFamily="34" charset="0"/>
-                <a:ea typeface="Helvetica Neue Light" pitchFamily="34" charset="-122"/>
-                <a:cs typeface="Helvetica Neue Light" pitchFamily="34" charset="-120"/>
-              </a:rPr>
-              <a:t>Guard: alerts ranked by severity; mark as read</a:t>
-            </a:r>
-            <a:endParaRPr lang="en-US" sz="1800" dirty="0"/>
-          </a:p>
-          <a:p>
-            <a:pPr marL="203200" indent="-203200">
-              <a:spcAft>
-                <a:spcPts val="600"/>
-              </a:spcAft>
-              <a:buSzPct val="100000"/>
-              <a:buChar char="•"/>
-            </a:pPr>
-            <a:r>
-              <a:rPr lang="en-US" sz="1800" dirty="0">
-                <a:solidFill>
-                  <a:srgbClr val="1F1F1F"/>
-                </a:solidFill>
-                <a:latin typeface="Helvetica Neue Light" pitchFamily="34" charset="0"/>
-                <a:ea typeface="Helvetica Neue Light" pitchFamily="34" charset="-122"/>
-                <a:cs typeface="Helvetica Neue Light" pitchFamily="34" charset="-120"/>
-              </a:rPr>
-              <a:t>Adapt: before and after allocation, and a reviewable buy and sell list</a:t>
-            </a:r>
-            <a:endParaRPr lang="en-US" sz="1800" dirty="0"/>
-          </a:p>
-        </p:txBody>
-      </p:sp>
-      <p:sp>
-        <p:nvSpPr>
-          <p:cNvPr id="7" name="Text 4"/>
-          <p:cNvSpPr txBox="1"/>
-          <p:nvPr/>
-        </p:nvSpPr>
-        <p:spPr>
-          <a:xfrm>
-            <a:off x="6583680" y="2468880"/>
-            <a:ext cx="5669280" cy="274320"/>
-          </a:xfrm>
-          <a:prstGeom prst="rect">
-            <a:avLst/>
-          </a:prstGeom>
-          <a:noFill/>
-          <a:ln/>
-        </p:spPr>
-        <p:txBody>
-          <a:bodyPr wrap="square" lIns="0" tIns="0" rIns="0" bIns="0" rtlCol="0" anchor="t"/>
-          <a:lstStyle/>
-          <a:p>
-            <a:pPr indent="0" marL="0">
-              <a:buNone/>
-            </a:pPr>
-            <a:r>
-              <a:rPr lang="en-US" sz="1280" spc="100" kern="0" dirty="0">
-                <a:solidFill>
-                  <a:srgbClr val="00868B"/>
-                </a:solidFill>
-                <a:latin typeface="Helvetica Neue" pitchFamily="34" charset="0"/>
-                <a:ea typeface="Helvetica Neue" pitchFamily="34" charset="-122"/>
-                <a:cs typeface="Helvetica Neue" pitchFamily="34" charset="-120"/>
-              </a:rPr>
-              <a:t>VALIDATION · PLANNED</a:t>
-            </a:r>
-            <a:endParaRPr lang="en-US" sz="1280" dirty="0"/>
-          </a:p>
-        </p:txBody>
-      </p:sp>
-      <p:sp>
-        <p:nvSpPr>
-          <p:cNvPr id="8" name="Text 5"/>
-          <p:cNvSpPr txBox="1"/>
-          <p:nvPr/>
-        </p:nvSpPr>
-        <p:spPr>
-          <a:xfrm>
-            <a:off x="6583680" y="2926080"/>
-            <a:ext cx="5669280" cy="4114800"/>
-          </a:xfrm>
-          <a:prstGeom prst="rect">
-            <a:avLst/>
-          </a:prstGeom>
-          <a:noFill/>
-          <a:ln/>
-        </p:spPr>
-        <p:txBody>
-          <a:bodyPr wrap="square" lIns="0" tIns="0" rIns="0" bIns="0" rtlCol="0" anchor="t"/>
-          <a:lstStyle/>
-          <a:p>
-            <a:pPr marL="203200" indent="-203200">
-              <a:spcAft>
-                <a:spcPts val="600"/>
-              </a:spcAft>
-              <a:buSzPct val="100000"/>
-              <a:buChar char="•"/>
-            </a:pPr>
-            <a:r>
-              <a:rPr lang="en-US" sz="1800" dirty="0">
-                <a:solidFill>
-                  <a:srgbClr val="1F1F1F"/>
-                </a:solidFill>
-                <a:latin typeface="Helvetica Neue Light" pitchFamily="34" charset="0"/>
-                <a:ea typeface="Helvetica Neue Light" pitchFamily="34" charset="-122"/>
-                <a:cs typeface="Helvetica Neue Light" pitchFamily="34" charset="-120"/>
-              </a:rPr>
-              <a:t>Five-person think-aloud on the share and dollar flows</a:t>
-            </a:r>
-            <a:endParaRPr lang="en-US" sz="1800" dirty="0"/>
-          </a:p>
-          <a:p>
-            <a:pPr marL="203200" indent="-203200">
-              <a:spcAft>
-                <a:spcPts val="600"/>
-              </a:spcAft>
-              <a:buSzPct val="100000"/>
-              <a:buChar char="•"/>
-            </a:pPr>
-            <a:r>
-              <a:rPr lang="en-US" sz="1800" dirty="0">
-                <a:solidFill>
-                  <a:srgbClr val="1F1F1F"/>
-                </a:solidFill>
-                <a:latin typeface="Helvetica Neue Light" pitchFamily="34" charset="0"/>
-                <a:ea typeface="Helvetica Neue Light" pitchFamily="34" charset="-122"/>
-                <a:cs typeface="Helvetica Neue Light" pitchFamily="34" charset="-120"/>
-              </a:rPr>
-              <a:t>Comprehension check on Insight, Prospect, Guard and Adapt labels</a:t>
-            </a:r>
-            <a:endParaRPr lang="en-US" sz="1800" dirty="0"/>
-          </a:p>
-          <a:p>
-            <a:pPr marL="203200" indent="-203200">
-              <a:spcAft>
-                <a:spcPts val="600"/>
-              </a:spcAft>
-              <a:buSzPct val="100000"/>
-              <a:buChar char="•"/>
-            </a:pPr>
-            <a:r>
-              <a:rPr lang="en-US" sz="1800" dirty="0">
-                <a:solidFill>
-                  <a:srgbClr val="1F1F1F"/>
-                </a:solidFill>
-                <a:latin typeface="Helvetica Neue Light" pitchFamily="34" charset="0"/>
-                <a:ea typeface="Helvetica Neue Light" pitchFamily="34" charset="-122"/>
-                <a:cs typeface="Helvetica Neue Light" pitchFamily="34" charset="-120"/>
-              </a:rPr>
-              <a:t>Card sort on the five tabs</a:t>
-            </a:r>
-            <a:endParaRPr lang="en-US" sz="1800" dirty="0"/>
-          </a:p>
-          <a:p>
-            <a:pPr marL="203200" indent="-203200">
-              <a:spcAft>
-                <a:spcPts val="600"/>
-              </a:spcAft>
-              <a:buSzPct val="100000"/>
-              <a:buChar char="•"/>
-            </a:pPr>
-            <a:r>
-              <a:rPr lang="en-US" sz="1800" dirty="0">
-                <a:solidFill>
-                  <a:srgbClr val="1F1F1F"/>
-                </a:solidFill>
-                <a:latin typeface="Helvetica Neue Light" pitchFamily="34" charset="0"/>
-                <a:ea typeface="Helvetica Neue Light" pitchFamily="34" charset="-122"/>
-                <a:cs typeface="Helvetica Neue Light" pitchFamily="34" charset="-120"/>
-              </a:rPr>
-              <a:t>Compliance review of trade and AI copy</a:t>
-            </a:r>
-            <a:endParaRPr lang="en-US" sz="1800" dirty="0"/>
-          </a:p>
-        </p:txBody>
-      </p:sp>
-      <p:pic>
-        <p:nvPicPr>
-          <p:cNvPr id="9" name="Image 1" descr="/tmp/meridian-deck/img/band-footer.png">    </p:cNvPr>
           <p:cNvPicPr>
             <a:picLocks noChangeAspect="1"/>
           </p:cNvPicPr>
@@ -27215,7 +27028,7 @@
                 <a:ea typeface="Helvetica Neue" pitchFamily="34" charset="-122"/>
                 <a:cs typeface="Helvetica Neue" pitchFamily="34" charset="-120"/>
               </a:rPr>
-              <a:t>08 · Implementation   Meridian Navigator</a:t>
+              <a:t>07 · Methodology   Meridian Navigator</a:t>
             </a:r>
             <a:endParaRPr lang="en-US" sz="1422" dirty="0"/>
           </a:p>
@@ -27254,7 +27067,7 @@
                 <a:ea typeface="Helvetica Neue Light" pitchFamily="34" charset="-122"/>
                 <a:cs typeface="Helvetica Neue Light" pitchFamily="34" charset="-120"/>
               </a:rPr>
-              <a:t>Built on SwiftUI, with tokens shared with Figma</a:t>
+              <a:t>How the AI behaves, and how we will test it</a:t>
             </a:r>
             <a:endParaRPr lang="en-US" sz="3200" dirty="0"/>
           </a:p>
@@ -27311,13 +27124,13 @@
             <a:r>
               <a:rPr lang="en-US" sz="1280" spc="100" kern="0" dirty="0">
                 <a:solidFill>
-                  <a:srgbClr val="C45A35"/>
+                  <a:srgbClr val="5B3F96"/>
                 </a:solidFill>
                 <a:latin typeface="Helvetica Neue" pitchFamily="34" charset="0"/>
                 <a:ea typeface="Helvetica Neue" pitchFamily="34" charset="-122"/>
                 <a:cs typeface="Helvetica Neue" pitchFamily="34" charset="-120"/>
               </a:rPr>
-              <a:t>WHAT IS BUILT</a:t>
+              <a:t>AI BEHAVIOR · DESIGNED, MOCK DATA</a:t>
             </a:r>
             <a:endParaRPr lang="en-US" sz="1280" dirty="0"/>
           </a:p>
@@ -27360,7 +27173,7 @@
                 <a:ea typeface="Helvetica Neue Light" pitchFamily="34" charset="-122"/>
                 <a:cs typeface="Helvetica Neue Light" pitchFamily="34" charset="-120"/>
               </a:rPr>
-              <a:t>MVVM: one ViewModel per screen</a:t>
+              <a:t>Insight: sentiment summaries, with the screen as the source</a:t>
             </a:r>
             <a:endParaRPr lang="en-US" sz="1800" dirty="0"/>
           </a:p>
@@ -27381,7 +27194,7 @@
                 <a:ea typeface="Helvetica Neue Light" pitchFamily="34" charset="-122"/>
                 <a:cs typeface="Helvetica Neue Light" pitchFamily="34" charset="-120"/>
               </a:rPr>
-              <a:t>MockAPIService with realistic data and a delay</a:t>
+              <a:t>Prospect: opportunity cards with upside and downside</a:t>
             </a:r>
             <a:endParaRPr lang="en-US" sz="1800" dirty="0"/>
           </a:p>
@@ -27402,7 +27215,7 @@
                 <a:ea typeface="Helvetica Neue Light" pitchFamily="34" charset="-122"/>
                 <a:cs typeface="Helvetica Neue Light" pitchFamily="34" charset="-120"/>
               </a:rPr>
-              <a:t>DesignTokens.swift: colors, type and spacing</a:t>
+              <a:t>Guard: alerts ranked by severity; mark as read</a:t>
             </a:r>
             <a:endParaRPr lang="en-US" sz="1800" dirty="0"/>
           </a:p>
@@ -27423,10 +27236,71 @@
                 <a:ea typeface="Helvetica Neue Light" pitchFamily="34" charset="-122"/>
                 <a:cs typeface="Helvetica Neue Light" pitchFamily="34" charset="-120"/>
               </a:rPr>
-              <a:t>AuthManager: Face ID and Touch ID, Keychain storage</a:t>
+              <a:t>Adapt: before and after allocation, and a reviewable buy and sell list</a:t>
             </a:r>
             <a:endParaRPr lang="en-US" sz="1800" dirty="0"/>
           </a:p>
+        </p:txBody>
+      </p:sp>
+      <p:sp>
+        <p:nvSpPr>
+          <p:cNvPr id="7" name="Text 4"/>
+          <p:cNvSpPr txBox="1"/>
+          <p:nvPr/>
+        </p:nvSpPr>
+        <p:spPr>
+          <a:xfrm>
+            <a:off x="6583680" y="2468880"/>
+            <a:ext cx="5669280" cy="274320"/>
+          </a:xfrm>
+          <a:prstGeom prst="rect">
+            <a:avLst/>
+          </a:prstGeom>
+          <a:noFill/>
+          <a:ln/>
+        </p:spPr>
+        <p:txBody>
+          <a:bodyPr wrap="square" lIns="0" tIns="0" rIns="0" bIns="0" rtlCol="0" anchor="t"/>
+          <a:lstStyle/>
+          <a:p>
+            <a:pPr indent="0" marL="0">
+              <a:buNone/>
+            </a:pPr>
+            <a:r>
+              <a:rPr lang="en-US" sz="1280" spc="100" kern="0" dirty="0">
+                <a:solidFill>
+                  <a:srgbClr val="00868B"/>
+                </a:solidFill>
+                <a:latin typeface="Helvetica Neue" pitchFamily="34" charset="0"/>
+                <a:ea typeface="Helvetica Neue" pitchFamily="34" charset="-122"/>
+                <a:cs typeface="Helvetica Neue" pitchFamily="34" charset="-120"/>
+              </a:rPr>
+              <a:t>VALIDATION · PLANNED</a:t>
+            </a:r>
+            <a:endParaRPr lang="en-US" sz="1280" dirty="0"/>
+          </a:p>
+        </p:txBody>
+      </p:sp>
+      <p:sp>
+        <p:nvSpPr>
+          <p:cNvPr id="8" name="Text 5"/>
+          <p:cNvSpPr txBox="1"/>
+          <p:nvPr/>
+        </p:nvSpPr>
+        <p:spPr>
+          <a:xfrm>
+            <a:off x="6583680" y="2926080"/>
+            <a:ext cx="5669280" cy="4114800"/>
+          </a:xfrm>
+          <a:prstGeom prst="rect">
+            <a:avLst/>
+          </a:prstGeom>
+          <a:noFill/>
+          <a:ln/>
+        </p:spPr>
+        <p:txBody>
+          <a:bodyPr wrap="square" lIns="0" tIns="0" rIns="0" bIns="0" rtlCol="0" anchor="t"/>
+          <a:lstStyle/>
           <a:p>
             <a:pPr marL="203200" indent="-203200">
               <a:spcAft>
@@ -27444,71 +27318,10 @@
                 <a:ea typeface="Helvetica Neue Light" pitchFamily="34" charset="-122"/>
                 <a:cs typeface="Helvetica Neue Light" pitchFamily="34" charset="-120"/>
               </a:rPr>
-              <a:t>Figma library mirrors the same tokens</a:t>
+              <a:t>Five-person think-aloud on the share and dollar flows</a:t>
             </a:r>
             <a:endParaRPr lang="en-US" sz="1800" dirty="0"/>
           </a:p>
-        </p:txBody>
-      </p:sp>
-      <p:sp>
-        <p:nvSpPr>
-          <p:cNvPr id="7" name="Text 4"/>
-          <p:cNvSpPr txBox="1"/>
-          <p:nvPr/>
-        </p:nvSpPr>
-        <p:spPr>
-          <a:xfrm>
-            <a:off x="6583680" y="2468880"/>
-            <a:ext cx="5669280" cy="274320"/>
-          </a:xfrm>
-          <a:prstGeom prst="rect">
-            <a:avLst/>
-          </a:prstGeom>
-          <a:noFill/>
-          <a:ln/>
-        </p:spPr>
-        <p:txBody>
-          <a:bodyPr wrap="square" lIns="0" tIns="0" rIns="0" bIns="0" rtlCol="0" anchor="t"/>
-          <a:lstStyle/>
-          <a:p>
-            <a:pPr indent="0" marL="0">
-              <a:buNone/>
-            </a:pPr>
-            <a:r>
-              <a:rPr lang="en-US" sz="1280" spc="100" kern="0" dirty="0">
-                <a:solidFill>
-                  <a:srgbClr val="744A6C"/>
-                </a:solidFill>
-                <a:latin typeface="Helvetica Neue" pitchFamily="34" charset="0"/>
-                <a:ea typeface="Helvetica Neue" pitchFamily="34" charset="-122"/>
-                <a:cs typeface="Helvetica Neue" pitchFamily="34" charset="-120"/>
-              </a:rPr>
-              <a:t>NEXT TO BUILD · PROPOSED</a:t>
-            </a:r>
-            <a:endParaRPr lang="en-US" sz="1280" dirty="0"/>
-          </a:p>
-        </p:txBody>
-      </p:sp>
-      <p:sp>
-        <p:nvSpPr>
-          <p:cNvPr id="8" name="Text 5"/>
-          <p:cNvSpPr txBox="1"/>
-          <p:nvPr/>
-        </p:nvSpPr>
-        <p:spPr>
-          <a:xfrm>
-            <a:off x="6583680" y="2926080"/>
-            <a:ext cx="5669280" cy="4114800"/>
-          </a:xfrm>
-          <a:prstGeom prst="rect">
-            <a:avLst/>
-          </a:prstGeom>
-          <a:noFill/>
-          <a:ln/>
-        </p:spPr>
-        <p:txBody>
-          <a:bodyPr wrap="square" lIns="0" tIns="0" rIns="0" bIns="0" rtlCol="0" anchor="t"/>
-          <a:lstStyle/>
           <a:p>
             <a:pPr marL="203200" indent="-203200">
               <a:spcAft>
@@ -27526,7 +27339,7 @@
                 <a:ea typeface="Helvetica Neue Light" pitchFamily="34" charset="-122"/>
                 <a:cs typeface="Helvetica Neue Light" pitchFamily="34" charset="-120"/>
               </a:rPr>
-              <a:t>Real market data and quotes behind the mock service</a:t>
+              <a:t>Comprehension check on Insight, Prospect, Guard and Adapt labels</a:t>
             </a:r>
             <a:endParaRPr lang="en-US" sz="1800" dirty="0"/>
           </a:p>
@@ -27547,7 +27360,7 @@
                 <a:ea typeface="Helvetica Neue Light" pitchFamily="34" charset="-122"/>
                 <a:cs typeface="Helvetica Neue Light" pitchFamily="34" charset="-120"/>
               </a:rPr>
-              <a:t>Brokerage connection for order placement</a:t>
+              <a:t>Card sort on the five tabs</a:t>
             </a:r>
             <a:endParaRPr lang="en-US" sz="1800" dirty="0"/>
           </a:p>
@@ -27568,28 +27381,7 @@
                 <a:ea typeface="Helvetica Neue Light" pitchFamily="34" charset="-122"/>
                 <a:cs typeface="Helvetica Neue Light" pitchFamily="34" charset="-120"/>
               </a:rPr>
-              <a:t>Session and authentication with a real backend</a:t>
-            </a:r>
-            <a:endParaRPr lang="en-US" sz="1800" dirty="0"/>
-          </a:p>
-          <a:p>
-            <a:pPr marL="203200" indent="-203200">
-              <a:spcAft>
-                <a:spcPts val="600"/>
-              </a:spcAft>
-              <a:buSzPct val="100000"/>
-              <a:buChar char="•"/>
-            </a:pPr>
-            <a:r>
-              <a:rPr lang="en-US" sz="1800" dirty="0">
-                <a:solidFill>
-                  <a:srgbClr val="1F1F1F"/>
-                </a:solidFill>
-                <a:latin typeface="Helvetica Neue Light" pitchFamily="34" charset="0"/>
-                <a:ea typeface="Helvetica Neue Light" pitchFamily="34" charset="-122"/>
-                <a:cs typeface="Helvetica Neue Light" pitchFamily="34" charset="-120"/>
-              </a:rPr>
-              <a:t>Audit log for trade and AI actions</a:t>
+              <a:t>Compliance review of trade and AI copy</a:t>
             </a:r>
             <a:endParaRPr lang="en-US" sz="1800" dirty="0"/>
           </a:p>
@@ -27677,7 +27469,7 @@
                 <a:ea typeface="Helvetica Neue" pitchFamily="34" charset="-122"/>
                 <a:cs typeface="Helvetica Neue" pitchFamily="34" charset="-120"/>
               </a:rPr>
-              <a:t>09 · Results &amp; impact   Meridian Navigator</a:t>
+              <a:t>08 · Implementation   Meridian Navigator</a:t>
             </a:r>
             <a:endParaRPr lang="en-US" sz="1422" dirty="0"/>
           </a:p>
@@ -27716,7 +27508,7 @@
                 <a:ea typeface="Helvetica Neue Light" pitchFamily="34" charset="-122"/>
                 <a:cs typeface="Helvetica Neue Light" pitchFamily="34" charset="-120"/>
               </a:rPr>
-              <a:t>What exists today, and what we still need to measure</a:t>
+              <a:t>Built on SwiftUI, with tokens shared with Figma</a:t>
             </a:r>
             <a:endParaRPr lang="en-US" sz="3200" dirty="0"/>
           </a:p>
@@ -27748,39 +27540,14 @@
       </p:pic>
       <p:sp>
         <p:nvSpPr>
-          <p:cNvPr id="5" name="Shape 2"/>
-          <p:cNvSpPr/>
+          <p:cNvPr id="5" name="Text 2"/>
+          <p:cNvSpPr txBox="1"/>
           <p:nvPr/>
         </p:nvSpPr>
         <p:spPr>
           <a:xfrm>
             <a:off x="457200" y="2468880"/>
-            <a:ext cx="2851099" cy="2926080"/>
-          </a:xfrm>
-          <a:prstGeom prst="rect">
-            <a:avLst/>
-          </a:prstGeom>
-          <a:solidFill>
-            <a:srgbClr val="C45A35"/>
-          </a:solidFill>
-          <a:ln w="12700">
-            <a:solidFill>
-              <a:srgbClr val="C45A35"/>
-            </a:solidFill>
-            <a:prstDash val="solid"/>
-          </a:ln>
-        </p:spPr>
-      </p:sp>
-      <p:sp>
-        <p:nvSpPr>
-          <p:cNvPr id="6" name="Text 3"/>
-          <p:cNvSpPr txBox="1"/>
-          <p:nvPr/>
-        </p:nvSpPr>
-        <p:spPr>
-          <a:xfrm>
-            <a:off x="777240" y="2743200"/>
-            <a:ext cx="2211019" cy="1371600"/>
+            <a:ext cx="5669280" cy="274320"/>
           </a:xfrm>
           <a:prstGeom prst="rect">
             <a:avLst/>
@@ -27796,94 +27563,157 @@
               <a:buNone/>
             </a:pPr>
             <a:r>
-              <a:rPr lang="en-US" sz="8000" b="1" dirty="0">
-                <a:solidFill>
-                  <a:srgbClr val="FFFFFF"/>
+              <a:rPr lang="en-US" sz="1280" spc="100" kern="0" dirty="0">
+                <a:solidFill>
+                  <a:srgbClr val="C45A35"/>
                 </a:solidFill>
                 <a:latin typeface="Helvetica Neue" pitchFamily="34" charset="0"/>
                 <a:ea typeface="Helvetica Neue" pitchFamily="34" charset="-122"/>
                 <a:cs typeface="Helvetica Neue" pitchFamily="34" charset="-120"/>
               </a:rPr>
-              <a:t>5</a:t>
-            </a:r>
-            <a:endParaRPr lang="en-US" sz="8000" dirty="0"/>
-          </a:p>
-        </p:txBody>
-      </p:sp>
-      <p:sp>
-        <p:nvSpPr>
-          <p:cNvPr id="7" name="Text 4"/>
-          <p:cNvSpPr txBox="1"/>
-          <p:nvPr/>
-        </p:nvSpPr>
-        <p:spPr>
-          <a:xfrm>
-            <a:off x="777240" y="4297680"/>
-            <a:ext cx="2211019" cy="914400"/>
-          </a:xfrm>
-          <a:prstGeom prst="rect">
-            <a:avLst/>
-          </a:prstGeom>
-          <a:noFill/>
-          <a:ln/>
-        </p:spPr>
-        <p:txBody>
-          <a:bodyPr wrap="square" lIns="0" tIns="0" rIns="0" bIns="0" rtlCol="0" anchor="t"/>
-          <a:lstStyle/>
-          <a:p>
-            <a:pPr indent="0" marL="0">
-              <a:buNone/>
-            </a:pPr>
-            <a:r>
-              <a:rPr lang="en-US" sz="1700" dirty="0">
-                <a:solidFill>
-                  <a:srgbClr val="FFFFFF"/>
+              <a:t>WHAT IS BUILT</a:t>
+            </a:r>
+            <a:endParaRPr lang="en-US" sz="1280" dirty="0"/>
+          </a:p>
+        </p:txBody>
+      </p:sp>
+      <p:sp>
+        <p:nvSpPr>
+          <p:cNvPr id="6" name="Text 3"/>
+          <p:cNvSpPr txBox="1"/>
+          <p:nvPr/>
+        </p:nvSpPr>
+        <p:spPr>
+          <a:xfrm>
+            <a:off x="457200" y="2926080"/>
+            <a:ext cx="5669280" cy="4114800"/>
+          </a:xfrm>
+          <a:prstGeom prst="rect">
+            <a:avLst/>
+          </a:prstGeom>
+          <a:noFill/>
+          <a:ln/>
+        </p:spPr>
+        <p:txBody>
+          <a:bodyPr wrap="square" lIns="0" tIns="0" rIns="0" bIns="0" rtlCol="0" anchor="t"/>
+          <a:lstStyle/>
+          <a:p>
+            <a:pPr marL="203200" indent="-203200">
+              <a:spcAft>
+                <a:spcPts val="600"/>
+              </a:spcAft>
+              <a:buSzPct val="100000"/>
+              <a:buChar char="•"/>
+            </a:pPr>
+            <a:r>
+              <a:rPr lang="en-US" sz="1800" dirty="0">
+                <a:solidFill>
+                  <a:srgbClr val="1F1F1F"/>
                 </a:solidFill>
                 <a:latin typeface="Helvetica Neue Light" pitchFamily="34" charset="0"/>
                 <a:ea typeface="Helvetica Neue Light" pitchFamily="34" charset="-122"/>
                 <a:cs typeface="Helvetica Neue Light" pitchFamily="34" charset="-120"/>
               </a:rPr>
-              <a:t>core iOS screens, each with a ViewModel</a:t>
-            </a:r>
-            <a:endParaRPr lang="en-US" sz="1700" dirty="0"/>
-          </a:p>
-        </p:txBody>
-      </p:sp>
-      <p:sp>
-        <p:nvSpPr>
-          <p:cNvPr id="8" name="Shape 5"/>
-          <p:cNvSpPr/>
-          <p:nvPr/>
-        </p:nvSpPr>
-        <p:spPr>
-          <a:xfrm>
-            <a:off x="3536899" y="2468880"/>
-            <a:ext cx="2851099" cy="2926080"/>
-          </a:xfrm>
-          <a:prstGeom prst="rect">
-            <a:avLst/>
-          </a:prstGeom>
-          <a:solidFill>
-            <a:srgbClr val="5B3F96"/>
-          </a:solidFill>
-          <a:ln w="12700">
-            <a:solidFill>
-              <a:srgbClr val="5B3F96"/>
-            </a:solidFill>
-            <a:prstDash val="solid"/>
-          </a:ln>
-        </p:spPr>
-      </p:sp>
-      <p:sp>
-        <p:nvSpPr>
-          <p:cNvPr id="9" name="Text 6"/>
-          <p:cNvSpPr txBox="1"/>
-          <p:nvPr/>
-        </p:nvSpPr>
-        <p:spPr>
-          <a:xfrm>
-            <a:off x="3856939" y="2743200"/>
-            <a:ext cx="2211019" cy="1371600"/>
+              <a:t>MVVM: one ViewModel per screen</a:t>
+            </a:r>
+            <a:endParaRPr lang="en-US" sz="1800" dirty="0"/>
+          </a:p>
+          <a:p>
+            <a:pPr marL="203200" indent="-203200">
+              <a:spcAft>
+                <a:spcPts val="600"/>
+              </a:spcAft>
+              <a:buSzPct val="100000"/>
+              <a:buChar char="•"/>
+            </a:pPr>
+            <a:r>
+              <a:rPr lang="en-US" sz="1800" dirty="0">
+                <a:solidFill>
+                  <a:srgbClr val="1F1F1F"/>
+                </a:solidFill>
+                <a:latin typeface="Helvetica Neue Light" pitchFamily="34" charset="0"/>
+                <a:ea typeface="Helvetica Neue Light" pitchFamily="34" charset="-122"/>
+                <a:cs typeface="Helvetica Neue Light" pitchFamily="34" charset="-120"/>
+              </a:rPr>
+              <a:t>MockAPIService with realistic data and a delay</a:t>
+            </a:r>
+            <a:endParaRPr lang="en-US" sz="1800" dirty="0"/>
+          </a:p>
+          <a:p>
+            <a:pPr marL="203200" indent="-203200">
+              <a:spcAft>
+                <a:spcPts val="600"/>
+              </a:spcAft>
+              <a:buSzPct val="100000"/>
+              <a:buChar char="•"/>
+            </a:pPr>
+            <a:r>
+              <a:rPr lang="en-US" sz="1800" dirty="0">
+                <a:solidFill>
+                  <a:srgbClr val="1F1F1F"/>
+                </a:solidFill>
+                <a:latin typeface="Helvetica Neue Light" pitchFamily="34" charset="0"/>
+                <a:ea typeface="Helvetica Neue Light" pitchFamily="34" charset="-122"/>
+                <a:cs typeface="Helvetica Neue Light" pitchFamily="34" charset="-120"/>
+              </a:rPr>
+              <a:t>DesignTokens.swift: colors, type and spacing</a:t>
+            </a:r>
+            <a:endParaRPr lang="en-US" sz="1800" dirty="0"/>
+          </a:p>
+          <a:p>
+            <a:pPr marL="203200" indent="-203200">
+              <a:spcAft>
+                <a:spcPts val="600"/>
+              </a:spcAft>
+              <a:buSzPct val="100000"/>
+              <a:buChar char="•"/>
+            </a:pPr>
+            <a:r>
+              <a:rPr lang="en-US" sz="1800" dirty="0">
+                <a:solidFill>
+                  <a:srgbClr val="1F1F1F"/>
+                </a:solidFill>
+                <a:latin typeface="Helvetica Neue Light" pitchFamily="34" charset="0"/>
+                <a:ea typeface="Helvetica Neue Light" pitchFamily="34" charset="-122"/>
+                <a:cs typeface="Helvetica Neue Light" pitchFamily="34" charset="-120"/>
+              </a:rPr>
+              <a:t>AuthManager: Face ID and Touch ID, Keychain storage</a:t>
+            </a:r>
+            <a:endParaRPr lang="en-US" sz="1800" dirty="0"/>
+          </a:p>
+          <a:p>
+            <a:pPr marL="203200" indent="-203200">
+              <a:spcAft>
+                <a:spcPts val="600"/>
+              </a:spcAft>
+              <a:buSzPct val="100000"/>
+              <a:buChar char="•"/>
+            </a:pPr>
+            <a:r>
+              <a:rPr lang="en-US" sz="1800" dirty="0">
+                <a:solidFill>
+                  <a:srgbClr val="1F1F1F"/>
+                </a:solidFill>
+                <a:latin typeface="Helvetica Neue Light" pitchFamily="34" charset="0"/>
+                <a:ea typeface="Helvetica Neue Light" pitchFamily="34" charset="-122"/>
+                <a:cs typeface="Helvetica Neue Light" pitchFamily="34" charset="-120"/>
+              </a:rPr>
+              <a:t>Figma library mirrors the same tokens</a:t>
+            </a:r>
+            <a:endParaRPr lang="en-US" sz="1800" dirty="0"/>
+          </a:p>
+        </p:txBody>
+      </p:sp>
+      <p:sp>
+        <p:nvSpPr>
+          <p:cNvPr id="7" name="Text 4"/>
+          <p:cNvSpPr txBox="1"/>
+          <p:nvPr/>
+        </p:nvSpPr>
+        <p:spPr>
+          <a:xfrm>
+            <a:off x="6583680" y="2468880"/>
+            <a:ext cx="5669280" cy="274320"/>
           </a:xfrm>
           <a:prstGeom prst="rect">
             <a:avLst/>
@@ -27899,330 +27729,113 @@
               <a:buNone/>
             </a:pPr>
             <a:r>
-              <a:rPr lang="en-US" sz="8000" b="1" dirty="0">
-                <a:solidFill>
-                  <a:srgbClr val="FFFFFF"/>
+              <a:rPr lang="en-US" sz="1280" spc="100" kern="0" dirty="0">
+                <a:solidFill>
+                  <a:srgbClr val="744A6C"/>
                 </a:solidFill>
                 <a:latin typeface="Helvetica Neue" pitchFamily="34" charset="0"/>
                 <a:ea typeface="Helvetica Neue" pitchFamily="34" charset="-122"/>
                 <a:cs typeface="Helvetica Neue" pitchFamily="34" charset="-120"/>
               </a:rPr>
-              <a:t>8</a:t>
-            </a:r>
-            <a:endParaRPr lang="en-US" sz="8000" dirty="0"/>
-          </a:p>
-        </p:txBody>
-      </p:sp>
-      <p:sp>
-        <p:nvSpPr>
-          <p:cNvPr id="10" name="Text 7"/>
-          <p:cNvSpPr txBox="1"/>
-          <p:nvPr/>
-        </p:nvSpPr>
-        <p:spPr>
-          <a:xfrm>
-            <a:off x="3856939" y="4297680"/>
-            <a:ext cx="2211019" cy="914400"/>
-          </a:xfrm>
-          <a:prstGeom prst="rect">
-            <a:avLst/>
-          </a:prstGeom>
-          <a:noFill/>
-          <a:ln/>
-        </p:spPr>
-        <p:txBody>
-          <a:bodyPr wrap="square" lIns="0" tIns="0" rIns="0" bIns="0" rtlCol="0" anchor="t"/>
-          <a:lstStyle/>
-          <a:p>
-            <a:pPr indent="0" marL="0">
-              <a:buNone/>
-            </a:pPr>
-            <a:r>
-              <a:rPr lang="en-US" sz="1700" dirty="0">
-                <a:solidFill>
-                  <a:srgbClr val="FFFFFF"/>
+              <a:t>NEXT TO BUILD · PROPOSED</a:t>
+            </a:r>
+            <a:endParaRPr lang="en-US" sz="1280" dirty="0"/>
+          </a:p>
+        </p:txBody>
+      </p:sp>
+      <p:sp>
+        <p:nvSpPr>
+          <p:cNvPr id="8" name="Text 5"/>
+          <p:cNvSpPr txBox="1"/>
+          <p:nvPr/>
+        </p:nvSpPr>
+        <p:spPr>
+          <a:xfrm>
+            <a:off x="6583680" y="2926080"/>
+            <a:ext cx="5669280" cy="4114800"/>
+          </a:xfrm>
+          <a:prstGeom prst="rect">
+            <a:avLst/>
+          </a:prstGeom>
+          <a:noFill/>
+          <a:ln/>
+        </p:spPr>
+        <p:txBody>
+          <a:bodyPr wrap="square" lIns="0" tIns="0" rIns="0" bIns="0" rtlCol="0" anchor="t"/>
+          <a:lstStyle/>
+          <a:p>
+            <a:pPr marL="203200" indent="-203200">
+              <a:spcAft>
+                <a:spcPts val="600"/>
+              </a:spcAft>
+              <a:buSzPct val="100000"/>
+              <a:buChar char="•"/>
+            </a:pPr>
+            <a:r>
+              <a:rPr lang="en-US" sz="1800" dirty="0">
+                <a:solidFill>
+                  <a:srgbClr val="1F1F1F"/>
                 </a:solidFill>
                 <a:latin typeface="Helvetica Neue Light" pitchFamily="34" charset="0"/>
                 <a:ea typeface="Helvetica Neue Light" pitchFamily="34" charset="-122"/>
                 <a:cs typeface="Helvetica Neue Light" pitchFamily="34" charset="-120"/>
               </a:rPr>
-              <a:t>steps in each trade flow: share and dollar</a:t>
-            </a:r>
-            <a:endParaRPr lang="en-US" sz="1700" dirty="0"/>
-          </a:p>
-        </p:txBody>
-      </p:sp>
-      <p:sp>
-        <p:nvSpPr>
-          <p:cNvPr id="11" name="Shape 8"/>
-          <p:cNvSpPr/>
-          <p:nvPr/>
-        </p:nvSpPr>
-        <p:spPr>
-          <a:xfrm>
-            <a:off x="6616598" y="2468880"/>
-            <a:ext cx="2851099" cy="2926080"/>
-          </a:xfrm>
-          <a:prstGeom prst="rect">
-            <a:avLst/>
-          </a:prstGeom>
-          <a:solidFill>
-            <a:srgbClr val="00868B"/>
-          </a:solidFill>
-          <a:ln w="12700">
-            <a:solidFill>
-              <a:srgbClr val="00868B"/>
-            </a:solidFill>
-            <a:prstDash val="solid"/>
-          </a:ln>
-        </p:spPr>
-      </p:sp>
-      <p:sp>
-        <p:nvSpPr>
-          <p:cNvPr id="12" name="Text 9"/>
-          <p:cNvSpPr txBox="1"/>
-          <p:nvPr/>
-        </p:nvSpPr>
-        <p:spPr>
-          <a:xfrm>
-            <a:off x="6936638" y="2743200"/>
-            <a:ext cx="2211019" cy="1371600"/>
-          </a:xfrm>
-          <a:prstGeom prst="rect">
-            <a:avLst/>
-          </a:prstGeom>
-          <a:noFill/>
-          <a:ln/>
-        </p:spPr>
-        <p:txBody>
-          <a:bodyPr wrap="square" lIns="0" tIns="0" rIns="0" bIns="0" rtlCol="0" anchor="t"/>
-          <a:lstStyle/>
-          <a:p>
-            <a:pPr indent="0" marL="0">
-              <a:buNone/>
-            </a:pPr>
-            <a:r>
-              <a:rPr lang="en-US" sz="8000" b="1" dirty="0">
-                <a:solidFill>
-                  <a:srgbClr val="FFFFFF"/>
-                </a:solidFill>
-                <a:latin typeface="Helvetica Neue" pitchFamily="34" charset="0"/>
-                <a:ea typeface="Helvetica Neue" pitchFamily="34" charset="-122"/>
-                <a:cs typeface="Helvetica Neue" pitchFamily="34" charset="-120"/>
-              </a:rPr>
-              <a:t>3</a:t>
-            </a:r>
-            <a:endParaRPr lang="en-US" sz="8000" dirty="0"/>
-          </a:p>
-        </p:txBody>
-      </p:sp>
-      <p:sp>
-        <p:nvSpPr>
-          <p:cNvPr id="13" name="Text 10"/>
-          <p:cNvSpPr txBox="1"/>
-          <p:nvPr/>
-        </p:nvSpPr>
-        <p:spPr>
-          <a:xfrm>
-            <a:off x="6936638" y="4297680"/>
-            <a:ext cx="2211019" cy="914400"/>
-          </a:xfrm>
-          <a:prstGeom prst="rect">
-            <a:avLst/>
-          </a:prstGeom>
-          <a:noFill/>
-          <a:ln/>
-        </p:spPr>
-        <p:txBody>
-          <a:bodyPr wrap="square" lIns="0" tIns="0" rIns="0" bIns="0" rtlCol="0" anchor="t"/>
-          <a:lstStyle/>
-          <a:p>
-            <a:pPr indent="0" marL="0">
-              <a:buNone/>
-            </a:pPr>
-            <a:r>
-              <a:rPr lang="en-US" sz="1700" dirty="0">
-                <a:solidFill>
-                  <a:srgbClr val="FFFFFF"/>
+              <a:t>Real market data and quotes behind the mock service</a:t>
+            </a:r>
+            <a:endParaRPr lang="en-US" sz="1800" dirty="0"/>
+          </a:p>
+          <a:p>
+            <a:pPr marL="203200" indent="-203200">
+              <a:spcAft>
+                <a:spcPts val="600"/>
+              </a:spcAft>
+              <a:buSzPct val="100000"/>
+              <a:buChar char="•"/>
+            </a:pPr>
+            <a:r>
+              <a:rPr lang="en-US" sz="1800" dirty="0">
+                <a:solidFill>
+                  <a:srgbClr val="1F1F1F"/>
                 </a:solidFill>
                 <a:latin typeface="Helvetica Neue Light" pitchFamily="34" charset="0"/>
                 <a:ea typeface="Helvetica Neue Light" pitchFamily="34" charset="-122"/>
                 <a:cs typeface="Helvetica Neue Light" pitchFamily="34" charset="-120"/>
               </a:rPr>
-              <a:t>interactive prototypes published, plus this deck</a:t>
-            </a:r>
-            <a:endParaRPr lang="en-US" sz="1700" dirty="0"/>
-          </a:p>
-        </p:txBody>
-      </p:sp>
-      <p:sp>
-        <p:nvSpPr>
-          <p:cNvPr id="14" name="Shape 11"/>
-          <p:cNvSpPr/>
-          <p:nvPr/>
-        </p:nvSpPr>
-        <p:spPr>
-          <a:xfrm>
-            <a:off x="9696298" y="2468880"/>
-            <a:ext cx="2851099" cy="2926080"/>
-          </a:xfrm>
-          <a:prstGeom prst="rect">
-            <a:avLst/>
-          </a:prstGeom>
-          <a:solidFill>
-            <a:srgbClr val="3A7D55"/>
-          </a:solidFill>
-          <a:ln w="12700">
-            <a:solidFill>
-              <a:srgbClr val="3A7D55"/>
-            </a:solidFill>
-            <a:prstDash val="solid"/>
-          </a:ln>
-        </p:spPr>
-      </p:sp>
-      <p:sp>
-        <p:nvSpPr>
-          <p:cNvPr id="15" name="Text 12"/>
-          <p:cNvSpPr txBox="1"/>
-          <p:nvPr/>
-        </p:nvSpPr>
-        <p:spPr>
-          <a:xfrm>
-            <a:off x="10016338" y="2743200"/>
-            <a:ext cx="2211019" cy="1371600"/>
-          </a:xfrm>
-          <a:prstGeom prst="rect">
-            <a:avLst/>
-          </a:prstGeom>
-          <a:noFill/>
-          <a:ln/>
-        </p:spPr>
-        <p:txBody>
-          <a:bodyPr wrap="square" lIns="0" tIns="0" rIns="0" bIns="0" rtlCol="0" anchor="t"/>
-          <a:lstStyle/>
-          <a:p>
-            <a:pPr indent="0" marL="0">
-              <a:buNone/>
-            </a:pPr>
-            <a:r>
-              <a:rPr lang="en-US" sz="8000" b="1" dirty="0">
-                <a:solidFill>
-                  <a:srgbClr val="FFFFFF"/>
-                </a:solidFill>
-                <a:latin typeface="Helvetica Neue" pitchFamily="34" charset="0"/>
-                <a:ea typeface="Helvetica Neue" pitchFamily="34" charset="-122"/>
-                <a:cs typeface="Helvetica Neue" pitchFamily="34" charset="-120"/>
-              </a:rPr>
-              <a:t>20</a:t>
-            </a:r>
-            <a:endParaRPr lang="en-US" sz="8000" dirty="0"/>
-          </a:p>
-        </p:txBody>
-      </p:sp>
-      <p:sp>
-        <p:nvSpPr>
-          <p:cNvPr id="16" name="Text 13"/>
-          <p:cNvSpPr txBox="1"/>
-          <p:nvPr/>
-        </p:nvSpPr>
-        <p:spPr>
-          <a:xfrm>
-            <a:off x="10016338" y="4297680"/>
-            <a:ext cx="2211019" cy="914400"/>
-          </a:xfrm>
-          <a:prstGeom prst="rect">
-            <a:avLst/>
-          </a:prstGeom>
-          <a:noFill/>
-          <a:ln/>
-        </p:spPr>
-        <p:txBody>
-          <a:bodyPr wrap="square" lIns="0" tIns="0" rIns="0" bIns="0" rtlCol="0" anchor="t"/>
-          <a:lstStyle/>
-          <a:p>
-            <a:pPr indent="0" marL="0">
-              <a:buNone/>
-            </a:pPr>
-            <a:r>
-              <a:rPr lang="en-US" sz="1700" dirty="0">
-                <a:solidFill>
-                  <a:srgbClr val="FFFFFF"/>
+              <a:t>Brokerage connection for order placement</a:t>
+            </a:r>
+            <a:endParaRPr lang="en-US" sz="1800" dirty="0"/>
+          </a:p>
+          <a:p>
+            <a:pPr marL="203200" indent="-203200">
+              <a:spcAft>
+                <a:spcPts val="600"/>
+              </a:spcAft>
+              <a:buSzPct val="100000"/>
+              <a:buChar char="•"/>
+            </a:pPr>
+            <a:r>
+              <a:rPr lang="en-US" sz="1800" dirty="0">
+                <a:solidFill>
+                  <a:srgbClr val="1F1F1F"/>
                 </a:solidFill>
                 <a:latin typeface="Helvetica Neue Light" pitchFamily="34" charset="0"/>
                 <a:ea typeface="Helvetica Neue Light" pitchFamily="34" charset="-122"/>
                 <a:cs typeface="Helvetica Neue Light" pitchFamily="34" charset="-120"/>
               </a:rPr>
-              <a:t>hi-fi wireframe states on 06- Wireframes</a:t>
-            </a:r>
-            <a:endParaRPr lang="en-US" sz="1700" dirty="0"/>
-          </a:p>
-        </p:txBody>
-      </p:sp>
-      <p:sp>
-        <p:nvSpPr>
-          <p:cNvPr id="17" name="Text 14"/>
-          <p:cNvSpPr txBox="1"/>
-          <p:nvPr/>
-        </p:nvSpPr>
-        <p:spPr>
-          <a:xfrm>
-            <a:off x="457200" y="6035040"/>
-            <a:ext cx="12070080" cy="274320"/>
-          </a:xfrm>
-          <a:prstGeom prst="rect">
-            <a:avLst/>
-          </a:prstGeom>
-          <a:noFill/>
-          <a:ln/>
-        </p:spPr>
-        <p:txBody>
-          <a:bodyPr wrap="square" lIns="0" tIns="0" rIns="0" bIns="0" rtlCol="0" anchor="t"/>
-          <a:lstStyle/>
-          <a:p>
-            <a:pPr indent="0" marL="0">
-              <a:buNone/>
-            </a:pPr>
-            <a:r>
-              <a:rPr lang="en-US" sz="1280" spc="100" kern="0" dirty="0">
-                <a:solidFill>
-                  <a:srgbClr val="A12A37"/>
-                </a:solidFill>
-                <a:latin typeface="Helvetica Neue" pitchFamily="34" charset="0"/>
-                <a:ea typeface="Helvetica Neue" pitchFamily="34" charset="-122"/>
-                <a:cs typeface="Helvetica Neue" pitchFamily="34" charset="-120"/>
-              </a:rPr>
-              <a:t>OUTCOMES · NOT YET MEASURED</a:t>
-            </a:r>
-            <a:endParaRPr lang="en-US" sz="1280" dirty="0"/>
-          </a:p>
-        </p:txBody>
-      </p:sp>
-      <p:sp>
-        <p:nvSpPr>
-          <p:cNvPr id="18" name="Text 15"/>
-          <p:cNvSpPr txBox="1"/>
-          <p:nvPr/>
-        </p:nvSpPr>
-        <p:spPr>
-          <a:xfrm>
-            <a:off x="457200" y="6400800"/>
-            <a:ext cx="12070080" cy="1463040"/>
-          </a:xfrm>
-          <a:prstGeom prst="rect">
-            <a:avLst/>
-          </a:prstGeom>
-          <a:noFill/>
-          <a:ln/>
-        </p:spPr>
-        <p:txBody>
-          <a:bodyPr wrap="square" lIns="0" tIns="0" rIns="0" bIns="0" rtlCol="0" anchor="t"/>
-          <a:lstStyle/>
-          <a:p>
-            <a:pPr indent="0" marL="0">
-              <a:buNone/>
-            </a:pPr>
-            <a:r>
-              <a:rPr lang="en-US" sz="2000" dirty="0">
+              <a:t>Session and authentication with a real backend</a:t>
+            </a:r>
+            <a:endParaRPr lang="en-US" sz="1800" dirty="0"/>
+          </a:p>
+          <a:p>
+            <a:pPr marL="203200" indent="-203200">
+              <a:spcAft>
+                <a:spcPts val="600"/>
+              </a:spcAft>
+              <a:buSzPct val="100000"/>
+              <a:buChar char="•"/>
+            </a:pPr>
+            <a:r>
+              <a:rPr lang="en-US" sz="1800" dirty="0">
                 <a:solidFill>
                   <a:srgbClr val="1F1F1F"/>
                 </a:solidFill>
@@ -28230,15 +27843,15 @@
                 <a:ea typeface="Helvetica Neue Light" pitchFamily="34" charset="-122"/>
                 <a:cs typeface="Helvetica Neue Light" pitchFamily="34" charset="-120"/>
               </a:rPr>
-              <a:t>Time to complete a trade, task success, the share of users who open an AI screen in week one, and a usability score. Targets are planned and will be set with stakeholders before the first test.</a:t>
-            </a:r>
-            <a:endParaRPr lang="en-US" sz="2000" dirty="0"/>
+              <a:t>Audit log for trade and AI actions</a:t>
+            </a:r>
+            <a:endParaRPr lang="en-US" sz="1800" dirty="0"/>
           </a:p>
         </p:txBody>
       </p:sp>
       <p:pic>
         <p:nvPicPr>
-          <p:cNvPr id="19" name="Image 1" descr="/tmp/meridian-deck/img/band-footer.png">    </p:cNvPr>
+          <p:cNvPr id="9" name="Image 1" descr="/tmp/meridian-deck/img/band-footer.png">    </p:cNvPr>
           <p:cNvPicPr>
             <a:picLocks noChangeAspect="1"/>
           </p:cNvPicPr>
@@ -28318,7 +27931,7 @@
                 <a:ea typeface="Helvetica Neue" pitchFamily="34" charset="-122"/>
                 <a:cs typeface="Helvetica Neue" pitchFamily="34" charset="-120"/>
               </a:rPr>
-              <a:t>10 · Learnings &amp; next steps   Meridian Navigator</a:t>
+              <a:t>09 · Results &amp; impact   Meridian Navigator</a:t>
             </a:r>
             <a:endParaRPr lang="en-US" sz="1422" dirty="0"/>
           </a:p>
@@ -28357,7 +27970,7 @@
                 <a:ea typeface="Helvetica Neue Light" pitchFamily="34" charset="-122"/>
                 <a:cs typeface="Helvetica Neue Light" pitchFamily="34" charset="-120"/>
               </a:rPr>
-              <a:t>What building this taught me, and what comes next</a:t>
+              <a:t>What exists today, and what we still need to measure</a:t>
             </a:r>
             <a:endParaRPr lang="en-US" sz="3200" dirty="0"/>
           </a:p>
@@ -28389,55 +28002,16 @@
       </p:pic>
       <p:sp>
         <p:nvSpPr>
-          <p:cNvPr id="5" name="Text 2"/>
-          <p:cNvSpPr txBox="1"/>
+          <p:cNvPr id="5" name="Shape 2"/>
+          <p:cNvSpPr/>
           <p:nvPr/>
         </p:nvSpPr>
         <p:spPr>
           <a:xfrm>
             <a:off x="457200" y="2468880"/>
-            <a:ext cx="5669280" cy="274320"/>
-          </a:xfrm>
-          <a:prstGeom prst="rect">
-            <a:avLst/>
-          </a:prstGeom>
-          <a:noFill/>
-          <a:ln/>
-        </p:spPr>
-        <p:txBody>
-          <a:bodyPr wrap="square" lIns="0" tIns="0" rIns="0" bIns="0" rtlCol="0" anchor="t"/>
-          <a:lstStyle/>
-          <a:p>
-            <a:pPr indent="0" marL="0">
-              <a:buNone/>
-            </a:pPr>
-            <a:r>
-              <a:rPr lang="en-US" sz="1280" spc="100" kern="0" dirty="0">
-                <a:solidFill>
-                  <a:srgbClr val="C45A35"/>
-                </a:solidFill>
-                <a:latin typeface="Helvetica Neue" pitchFamily="34" charset="0"/>
-                <a:ea typeface="Helvetica Neue" pitchFamily="34" charset="-122"/>
-                <a:cs typeface="Helvetica Neue" pitchFamily="34" charset="-120"/>
-              </a:rPr>
-              <a:t>LEARNINGS</a:t>
-            </a:r>
-            <a:endParaRPr lang="en-US" sz="1280" dirty="0"/>
-          </a:p>
-        </p:txBody>
-      </p:sp>
-      <p:sp>
-        <p:nvSpPr>
-          <p:cNvPr id="6" name="Shape 3"/>
-          <p:cNvSpPr/>
-          <p:nvPr/>
-        </p:nvSpPr>
-        <p:spPr>
-          <a:xfrm>
-            <a:off x="457200" y="3017520"/>
-            <a:ext cx="420624" cy="420624"/>
-          </a:xfrm>
-          <a:prstGeom prst="ellipse">
+            <a:ext cx="2851099" cy="2926080"/>
+          </a:xfrm>
+          <a:prstGeom prst="rect">
             <a:avLst/>
           </a:prstGeom>
           <a:solidFill>
@@ -28453,30 +28027,30 @@
       </p:sp>
       <p:sp>
         <p:nvSpPr>
-          <p:cNvPr id="7" name="Text 4"/>
-          <p:cNvSpPr txBox="1"/>
-          <p:nvPr/>
-        </p:nvSpPr>
-        <p:spPr>
-          <a:xfrm>
-            <a:off x="457200" y="3081528"/>
-            <a:ext cx="420624" cy="292608"/>
-          </a:xfrm>
-          <a:prstGeom prst="rect">
-            <a:avLst/>
-          </a:prstGeom>
-          <a:noFill/>
-          <a:ln/>
-        </p:spPr>
-        <p:txBody>
-          <a:bodyPr wrap="square" lIns="0" tIns="0" rIns="0" bIns="0" rtlCol="0" anchor="t"/>
-          <a:lstStyle/>
-          <a:p>
-            <a:pPr algn="ctr" indent="0" marL="0">
-              <a:buNone/>
-            </a:pPr>
-            <a:r>
-              <a:rPr lang="en-US" sz="1564" b="1" dirty="0">
+          <p:cNvPr id="6" name="Text 3"/>
+          <p:cNvSpPr txBox="1"/>
+          <p:nvPr/>
+        </p:nvSpPr>
+        <p:spPr>
+          <a:xfrm>
+            <a:off x="777240" y="2743200"/>
+            <a:ext cx="2211019" cy="1371600"/>
+          </a:xfrm>
+          <a:prstGeom prst="rect">
+            <a:avLst/>
+          </a:prstGeom>
+          <a:noFill/>
+          <a:ln/>
+        </p:spPr>
+        <p:txBody>
+          <a:bodyPr wrap="square" lIns="0" tIns="0" rIns="0" bIns="0" rtlCol="0" anchor="t"/>
+          <a:lstStyle/>
+          <a:p>
+            <a:pPr indent="0" marL="0">
+              <a:buNone/>
+            </a:pPr>
+            <a:r>
+              <a:rPr lang="en-US" sz="8000" b="1" dirty="0">
                 <a:solidFill>
                   <a:srgbClr val="FFFFFF"/>
                 </a:solidFill>
@@ -28484,22 +28058,22 @@
                 <a:ea typeface="Helvetica Neue" pitchFamily="34" charset="-122"/>
                 <a:cs typeface="Helvetica Neue" pitchFamily="34" charset="-120"/>
               </a:rPr>
-              <a:t>1</a:t>
-            </a:r>
-            <a:endParaRPr lang="en-US" sz="1564" dirty="0"/>
-          </a:p>
-        </p:txBody>
-      </p:sp>
-      <p:sp>
-        <p:nvSpPr>
-          <p:cNvPr id="8" name="Text 5"/>
-          <p:cNvSpPr txBox="1"/>
-          <p:nvPr/>
-        </p:nvSpPr>
-        <p:spPr>
-          <a:xfrm>
-            <a:off x="1097280" y="3035808"/>
-            <a:ext cx="5120640" cy="1097280"/>
+              <a:t>5</a:t>
+            </a:r>
+            <a:endParaRPr lang="en-US" sz="8000" dirty="0"/>
+          </a:p>
+        </p:txBody>
+      </p:sp>
+      <p:sp>
+        <p:nvSpPr>
+          <p:cNvPr id="7" name="Text 4"/>
+          <p:cNvSpPr txBox="1"/>
+          <p:nvPr/>
+        </p:nvSpPr>
+        <p:spPr>
+          <a:xfrm>
+            <a:off x="777240" y="4297680"/>
+            <a:ext cx="2211019" cy="914400"/>
           </a:xfrm>
           <a:prstGeom prst="rect">
             <a:avLst/>
@@ -28515,40 +28089,40 @@
               <a:buNone/>
             </a:pPr>
             <a:r>
-              <a:rPr lang="en-US" sz="1800" dirty="0">
-                <a:solidFill>
-                  <a:srgbClr val="1F1F1F"/>
+              <a:rPr lang="en-US" sz="1700" dirty="0">
+                <a:solidFill>
+                  <a:srgbClr val="FFFFFF"/>
                 </a:solidFill>
                 <a:latin typeface="Helvetica Neue Light" pitchFamily="34" charset="0"/>
                 <a:ea typeface="Helvetica Neue Light" pitchFamily="34" charset="-122"/>
                 <a:cs typeface="Helvetica Neue Light" pitchFamily="34" charset="-120"/>
               </a:rPr>
-              <a:t>One token source for Figma and Swift keeps the two in step.</a:t>
-            </a:r>
-            <a:endParaRPr lang="en-US" sz="1800" dirty="0"/>
-          </a:p>
-        </p:txBody>
-      </p:sp>
-      <p:sp>
-        <p:nvSpPr>
-          <p:cNvPr id="9" name="Shape 6"/>
+              <a:t>core iOS screens, each with a ViewModel</a:t>
+            </a:r>
+            <a:endParaRPr lang="en-US" sz="1700" dirty="0"/>
+          </a:p>
+        </p:txBody>
+      </p:sp>
+      <p:sp>
+        <p:nvSpPr>
+          <p:cNvPr id="8" name="Shape 5"/>
           <p:cNvSpPr/>
           <p:nvPr/>
         </p:nvSpPr>
         <p:spPr>
           <a:xfrm>
-            <a:off x="457200" y="4389120"/>
-            <a:ext cx="420624" cy="420624"/>
-          </a:xfrm>
-          <a:prstGeom prst="ellipse">
+            <a:off x="3536899" y="2468880"/>
+            <a:ext cx="2851099" cy="2926080"/>
+          </a:xfrm>
+          <a:prstGeom prst="rect">
             <a:avLst/>
           </a:prstGeom>
           <a:solidFill>
-            <a:srgbClr val="C45A35"/>
+            <a:srgbClr val="5B3F96"/>
           </a:solidFill>
           <a:ln w="12700">
             <a:solidFill>
-              <a:srgbClr val="C45A35"/>
+              <a:srgbClr val="5B3F96"/>
             </a:solidFill>
             <a:prstDash val="solid"/>
           </a:ln>
@@ -28556,30 +28130,30 @@
       </p:sp>
       <p:sp>
         <p:nvSpPr>
-          <p:cNvPr id="10" name="Text 7"/>
-          <p:cNvSpPr txBox="1"/>
-          <p:nvPr/>
-        </p:nvSpPr>
-        <p:spPr>
-          <a:xfrm>
-            <a:off x="457200" y="4453128"/>
-            <a:ext cx="420624" cy="292608"/>
-          </a:xfrm>
-          <a:prstGeom prst="rect">
-            <a:avLst/>
-          </a:prstGeom>
-          <a:noFill/>
-          <a:ln/>
-        </p:spPr>
-        <p:txBody>
-          <a:bodyPr wrap="square" lIns="0" tIns="0" rIns="0" bIns="0" rtlCol="0" anchor="t"/>
-          <a:lstStyle/>
-          <a:p>
-            <a:pPr algn="ctr" indent="0" marL="0">
-              <a:buNone/>
-            </a:pPr>
-            <a:r>
-              <a:rPr lang="en-US" sz="1564" b="1" dirty="0">
+          <p:cNvPr id="9" name="Text 6"/>
+          <p:cNvSpPr txBox="1"/>
+          <p:nvPr/>
+        </p:nvSpPr>
+        <p:spPr>
+          <a:xfrm>
+            <a:off x="3856939" y="2743200"/>
+            <a:ext cx="2211019" cy="1371600"/>
+          </a:xfrm>
+          <a:prstGeom prst="rect">
+            <a:avLst/>
+          </a:prstGeom>
+          <a:noFill/>
+          <a:ln/>
+        </p:spPr>
+        <p:txBody>
+          <a:bodyPr wrap="square" lIns="0" tIns="0" rIns="0" bIns="0" rtlCol="0" anchor="t"/>
+          <a:lstStyle/>
+          <a:p>
+            <a:pPr indent="0" marL="0">
+              <a:buNone/>
+            </a:pPr>
+            <a:r>
+              <a:rPr lang="en-US" sz="8000" b="1" dirty="0">
                 <a:solidFill>
                   <a:srgbClr val="FFFFFF"/>
                 </a:solidFill>
@@ -28587,22 +28161,22 @@
                 <a:ea typeface="Helvetica Neue" pitchFamily="34" charset="-122"/>
                 <a:cs typeface="Helvetica Neue" pitchFamily="34" charset="-120"/>
               </a:rPr>
-              <a:t>2</a:t>
-            </a:r>
-            <a:endParaRPr lang="en-US" sz="1564" dirty="0"/>
-          </a:p>
-        </p:txBody>
-      </p:sp>
-      <p:sp>
-        <p:nvSpPr>
-          <p:cNvPr id="11" name="Text 8"/>
-          <p:cNvSpPr txBox="1"/>
-          <p:nvPr/>
-        </p:nvSpPr>
-        <p:spPr>
-          <a:xfrm>
-            <a:off x="1097280" y="4407408"/>
-            <a:ext cx="5120640" cy="1097280"/>
+              <a:t>8</a:t>
+            </a:r>
+            <a:endParaRPr lang="en-US" sz="8000" dirty="0"/>
+          </a:p>
+        </p:txBody>
+      </p:sp>
+      <p:sp>
+        <p:nvSpPr>
+          <p:cNvPr id="10" name="Text 7"/>
+          <p:cNvSpPr txBox="1"/>
+          <p:nvPr/>
+        </p:nvSpPr>
+        <p:spPr>
+          <a:xfrm>
+            <a:off x="3856939" y="4297680"/>
+            <a:ext cx="2211019" cy="914400"/>
           </a:xfrm>
           <a:prstGeom prst="rect">
             <a:avLst/>
@@ -28618,40 +28192,40 @@
               <a:buNone/>
             </a:pPr>
             <a:r>
-              <a:rPr lang="en-US" sz="1800" dirty="0">
-                <a:solidFill>
-                  <a:srgbClr val="1F1F1F"/>
+              <a:rPr lang="en-US" sz="1700" dirty="0">
+                <a:solidFill>
+                  <a:srgbClr val="FFFFFF"/>
                 </a:solidFill>
                 <a:latin typeface="Helvetica Neue Light" pitchFamily="34" charset="0"/>
                 <a:ea typeface="Helvetica Neue Light" pitchFamily="34" charset="-122"/>
                 <a:cs typeface="Helvetica Neue Light" pitchFamily="34" charset="-120"/>
               </a:rPr>
-              <a:t>Settle AI boundaries before more screens. Adapt’s buy and sell wording needs compliance first.</a:t>
-            </a:r>
-            <a:endParaRPr lang="en-US" sz="1800" dirty="0"/>
-          </a:p>
-        </p:txBody>
-      </p:sp>
-      <p:sp>
-        <p:nvSpPr>
-          <p:cNvPr id="12" name="Shape 9"/>
+              <a:t>steps in each trade flow: share and dollar</a:t>
+            </a:r>
+            <a:endParaRPr lang="en-US" sz="1700" dirty="0"/>
+          </a:p>
+        </p:txBody>
+      </p:sp>
+      <p:sp>
+        <p:nvSpPr>
+          <p:cNvPr id="11" name="Shape 8"/>
           <p:cNvSpPr/>
           <p:nvPr/>
         </p:nvSpPr>
         <p:spPr>
           <a:xfrm>
-            <a:off x="457200" y="5760720"/>
-            <a:ext cx="420624" cy="420624"/>
-          </a:xfrm>
-          <a:prstGeom prst="ellipse">
+            <a:off x="6616598" y="2468880"/>
+            <a:ext cx="2851099" cy="2926080"/>
+          </a:xfrm>
+          <a:prstGeom prst="rect">
             <a:avLst/>
           </a:prstGeom>
           <a:solidFill>
-            <a:srgbClr val="C45A35"/>
+            <a:srgbClr val="00868B"/>
           </a:solidFill>
           <a:ln w="12700">
             <a:solidFill>
-              <a:srgbClr val="C45A35"/>
+              <a:srgbClr val="00868B"/>
             </a:solidFill>
             <a:prstDash val="solid"/>
           </a:ln>
@@ -28659,30 +28233,30 @@
       </p:sp>
       <p:sp>
         <p:nvSpPr>
-          <p:cNvPr id="13" name="Text 10"/>
-          <p:cNvSpPr txBox="1"/>
-          <p:nvPr/>
-        </p:nvSpPr>
-        <p:spPr>
-          <a:xfrm>
-            <a:off x="457200" y="5824728"/>
-            <a:ext cx="420624" cy="292608"/>
-          </a:xfrm>
-          <a:prstGeom prst="rect">
-            <a:avLst/>
-          </a:prstGeom>
-          <a:noFill/>
-          <a:ln/>
-        </p:spPr>
-        <p:txBody>
-          <a:bodyPr wrap="square" lIns="0" tIns="0" rIns="0" bIns="0" rtlCol="0" anchor="t"/>
-          <a:lstStyle/>
-          <a:p>
-            <a:pPr algn="ctr" indent="0" marL="0">
-              <a:buNone/>
-            </a:pPr>
-            <a:r>
-              <a:rPr lang="en-US" sz="1564" b="1" dirty="0">
+          <p:cNvPr id="12" name="Text 9"/>
+          <p:cNvSpPr txBox="1"/>
+          <p:nvPr/>
+        </p:nvSpPr>
+        <p:spPr>
+          <a:xfrm>
+            <a:off x="6936638" y="2743200"/>
+            <a:ext cx="2211019" cy="1371600"/>
+          </a:xfrm>
+          <a:prstGeom prst="rect">
+            <a:avLst/>
+          </a:prstGeom>
+          <a:noFill/>
+          <a:ln/>
+        </p:spPr>
+        <p:txBody>
+          <a:bodyPr wrap="square" lIns="0" tIns="0" rIns="0" bIns="0" rtlCol="0" anchor="t"/>
+          <a:lstStyle/>
+          <a:p>
+            <a:pPr indent="0" marL="0">
+              <a:buNone/>
+            </a:pPr>
+            <a:r>
+              <a:rPr lang="en-US" sz="8000" b="1" dirty="0">
                 <a:solidFill>
                   <a:srgbClr val="FFFFFF"/>
                 </a:solidFill>
@@ -28692,20 +28266,20 @@
               </a:rPr>
               <a:t>3</a:t>
             </a:r>
-            <a:endParaRPr lang="en-US" sz="1564" dirty="0"/>
-          </a:p>
-        </p:txBody>
-      </p:sp>
-      <p:sp>
-        <p:nvSpPr>
-          <p:cNvPr id="14" name="Text 11"/>
-          <p:cNvSpPr txBox="1"/>
-          <p:nvPr/>
-        </p:nvSpPr>
-        <p:spPr>
-          <a:xfrm>
-            <a:off x="1097280" y="5779008"/>
-            <a:ext cx="5120640" cy="1097280"/>
+            <a:endParaRPr lang="en-US" sz="8000" dirty="0"/>
+          </a:p>
+        </p:txBody>
+      </p:sp>
+      <p:sp>
+        <p:nvSpPr>
+          <p:cNvPr id="13" name="Text 10"/>
+          <p:cNvSpPr txBox="1"/>
+          <p:nvPr/>
+        </p:nvSpPr>
+        <p:spPr>
+          <a:xfrm>
+            <a:off x="6936638" y="4297680"/>
+            <a:ext cx="2211019" cy="914400"/>
           </a:xfrm>
           <a:prstGeom prst="rect">
             <a:avLst/>
@@ -28721,40 +28295,40 @@
               <a:buNone/>
             </a:pPr>
             <a:r>
-              <a:rPr lang="en-US" sz="1800" dirty="0">
-                <a:solidFill>
-                  <a:srgbClr val="1F1F1F"/>
+              <a:rPr lang="en-US" sz="1700" dirty="0">
+                <a:solidFill>
+                  <a:srgbClr val="FFFFFF"/>
                 </a:solidFill>
                 <a:latin typeface="Helvetica Neue Light" pitchFamily="34" charset="0"/>
                 <a:ea typeface="Helvetica Neue Light" pitchFamily="34" charset="-122"/>
                 <a:cs typeface="Helvetica Neue Light" pitchFamily="34" charset="-120"/>
               </a:rPr>
-              <a:t>Mock data hides timing and error states, so design them explicitly.</a:t>
-            </a:r>
-            <a:endParaRPr lang="en-US" sz="1800" dirty="0"/>
-          </a:p>
-        </p:txBody>
-      </p:sp>
-      <p:sp>
-        <p:nvSpPr>
-          <p:cNvPr id="15" name="Shape 12"/>
+              <a:t>interactive prototypes published, plus this deck</a:t>
+            </a:r>
+            <a:endParaRPr lang="en-US" sz="1700" dirty="0"/>
+          </a:p>
+        </p:txBody>
+      </p:sp>
+      <p:sp>
+        <p:nvSpPr>
+          <p:cNvPr id="14" name="Shape 11"/>
           <p:cNvSpPr/>
           <p:nvPr/>
         </p:nvSpPr>
         <p:spPr>
           <a:xfrm>
-            <a:off x="457200" y="7132320"/>
-            <a:ext cx="420624" cy="420624"/>
-          </a:xfrm>
-          <a:prstGeom prst="ellipse">
+            <a:off x="9696298" y="2468880"/>
+            <a:ext cx="2851099" cy="2926080"/>
+          </a:xfrm>
+          <a:prstGeom prst="rect">
             <a:avLst/>
           </a:prstGeom>
           <a:solidFill>
-            <a:srgbClr val="C45A35"/>
+            <a:srgbClr val="3A7D55"/>
           </a:solidFill>
           <a:ln w="12700">
             <a:solidFill>
-              <a:srgbClr val="C45A35"/>
+              <a:srgbClr val="3A7D55"/>
             </a:solidFill>
             <a:prstDash val="solid"/>
           </a:ln>
@@ -28762,30 +28336,30 @@
       </p:sp>
       <p:sp>
         <p:nvSpPr>
-          <p:cNvPr id="16" name="Text 13"/>
-          <p:cNvSpPr txBox="1"/>
-          <p:nvPr/>
-        </p:nvSpPr>
-        <p:spPr>
-          <a:xfrm>
-            <a:off x="457200" y="7196328"/>
-            <a:ext cx="420624" cy="292608"/>
-          </a:xfrm>
-          <a:prstGeom prst="rect">
-            <a:avLst/>
-          </a:prstGeom>
-          <a:noFill/>
-          <a:ln/>
-        </p:spPr>
-        <p:txBody>
-          <a:bodyPr wrap="square" lIns="0" tIns="0" rIns="0" bIns="0" rtlCol="0" anchor="t"/>
-          <a:lstStyle/>
-          <a:p>
-            <a:pPr algn="ctr" indent="0" marL="0">
-              <a:buNone/>
-            </a:pPr>
-            <a:r>
-              <a:rPr lang="en-US" sz="1564" b="1" dirty="0">
+          <p:cNvPr id="15" name="Text 12"/>
+          <p:cNvSpPr txBox="1"/>
+          <p:nvPr/>
+        </p:nvSpPr>
+        <p:spPr>
+          <a:xfrm>
+            <a:off x="10016338" y="2743200"/>
+            <a:ext cx="2211019" cy="1371600"/>
+          </a:xfrm>
+          <a:prstGeom prst="rect">
+            <a:avLst/>
+          </a:prstGeom>
+          <a:noFill/>
+          <a:ln/>
+        </p:spPr>
+        <p:txBody>
+          <a:bodyPr wrap="square" lIns="0" tIns="0" rIns="0" bIns="0" rtlCol="0" anchor="t"/>
+          <a:lstStyle/>
+          <a:p>
+            <a:pPr indent="0" marL="0">
+              <a:buNone/>
+            </a:pPr>
+            <a:r>
+              <a:rPr lang="en-US" sz="8000" b="1" dirty="0">
                 <a:solidFill>
                   <a:srgbClr val="FFFFFF"/>
                 </a:solidFill>
@@ -28793,22 +28367,22 @@
                 <a:ea typeface="Helvetica Neue" pitchFamily="34" charset="-122"/>
                 <a:cs typeface="Helvetica Neue" pitchFamily="34" charset="-120"/>
               </a:rPr>
-              <a:t>4</a:t>
-            </a:r>
-            <a:endParaRPr lang="en-US" sz="1564" dirty="0"/>
-          </a:p>
-        </p:txBody>
-      </p:sp>
-      <p:sp>
-        <p:nvSpPr>
-          <p:cNvPr id="17" name="Text 14"/>
-          <p:cNvSpPr txBox="1"/>
-          <p:nvPr/>
-        </p:nvSpPr>
-        <p:spPr>
-          <a:xfrm>
-            <a:off x="1097280" y="7150608"/>
-            <a:ext cx="5120640" cy="1097280"/>
+              <a:t>20</a:t>
+            </a:r>
+            <a:endParaRPr lang="en-US" sz="8000" dirty="0"/>
+          </a:p>
+        </p:txBody>
+      </p:sp>
+      <p:sp>
+        <p:nvSpPr>
+          <p:cNvPr id="16" name="Text 13"/>
+          <p:cNvSpPr txBox="1"/>
+          <p:nvPr/>
+        </p:nvSpPr>
+        <p:spPr>
+          <a:xfrm>
+            <a:off x="10016338" y="4297680"/>
+            <a:ext cx="2211019" cy="914400"/>
           </a:xfrm>
           <a:prstGeom prst="rect">
             <a:avLst/>
@@ -28824,30 +28398,30 @@
               <a:buNone/>
             </a:pPr>
             <a:r>
-              <a:rPr lang="en-US" sz="1800" dirty="0">
-                <a:solidFill>
-                  <a:srgbClr val="1F1F1F"/>
+              <a:rPr lang="en-US" sz="1700" dirty="0">
+                <a:solidFill>
+                  <a:srgbClr val="FFFFFF"/>
                 </a:solidFill>
                 <a:latin typeface="Helvetica Neue Light" pitchFamily="34" charset="0"/>
                 <a:ea typeface="Helvetica Neue Light" pitchFamily="34" charset="-122"/>
                 <a:cs typeface="Helvetica Neue Light" pitchFamily="34" charset="-120"/>
               </a:rPr>
-              <a:t>Keep working documents in one place: the FigJam board.</a:t>
-            </a:r>
-            <a:endParaRPr lang="en-US" sz="1800" dirty="0"/>
-          </a:p>
-        </p:txBody>
-      </p:sp>
-      <p:sp>
-        <p:nvSpPr>
-          <p:cNvPr id="18" name="Text 15"/>
-          <p:cNvSpPr txBox="1"/>
-          <p:nvPr/>
-        </p:nvSpPr>
-        <p:spPr>
-          <a:xfrm>
-            <a:off x="6583680" y="2468880"/>
-            <a:ext cx="5669280" cy="274320"/>
+              <a:t>hi-fi wireframe states on 06- Wireframes</a:t>
+            </a:r>
+            <a:endParaRPr lang="en-US" sz="1700" dirty="0"/>
+          </a:p>
+        </p:txBody>
+      </p:sp>
+      <p:sp>
+        <p:nvSpPr>
+          <p:cNvPr id="17" name="Text 14"/>
+          <p:cNvSpPr txBox="1"/>
+          <p:nvPr/>
+        </p:nvSpPr>
+        <p:spPr>
+          <a:xfrm>
+            <a:off x="457200" y="6035040"/>
+            <a:ext cx="12070080" cy="274320"/>
           </a:xfrm>
           <a:prstGeom prst="rect">
             <a:avLst/>
@@ -28865,13 +28439,13 @@
             <a:r>
               <a:rPr lang="en-US" sz="1280" spc="100" kern="0" dirty="0">
                 <a:solidFill>
-                  <a:srgbClr val="5B3F96"/>
+                  <a:srgbClr val="A12A37"/>
                 </a:solidFill>
                 <a:latin typeface="Helvetica Neue" pitchFamily="34" charset="0"/>
                 <a:ea typeface="Helvetica Neue" pitchFamily="34" charset="-122"/>
                 <a:cs typeface="Helvetica Neue" pitchFamily="34" charset="-120"/>
               </a:rPr>
-              <a:t>NEXT STEPS</a:t>
+              <a:t>OUTCOMES · NOT YET MEASURED</a:t>
             </a:r>
             <a:endParaRPr lang="en-US" sz="1280" dirty="0"/>
           </a:p>
@@ -28879,34 +28453,30 @@
       </p:sp>
       <p:sp>
         <p:nvSpPr>
-          <p:cNvPr id="19" name="Text 16"/>
-          <p:cNvSpPr txBox="1"/>
-          <p:nvPr/>
-        </p:nvSpPr>
-        <p:spPr>
-          <a:xfrm>
-            <a:off x="6583680" y="3017520"/>
-            <a:ext cx="5669280" cy="5029200"/>
-          </a:xfrm>
-          <a:prstGeom prst="rect">
-            <a:avLst/>
-          </a:prstGeom>
-          <a:noFill/>
-          <a:ln/>
-        </p:spPr>
-        <p:txBody>
-          <a:bodyPr wrap="square" lIns="0" tIns="0" rIns="0" bIns="0" rtlCol="0" anchor="t"/>
-          <a:lstStyle/>
-          <a:p>
-            <a:pPr marL="203200" indent="-203200">
-              <a:spcAft>
-                <a:spcPts val="600"/>
-              </a:spcAft>
-              <a:buSzPct val="100000"/>
-              <a:buChar char="•"/>
-            </a:pPr>
-            <a:r>
-              <a:rPr lang="en-US" sz="1800" dirty="0">
+          <p:cNvPr id="18" name="Text 15"/>
+          <p:cNvSpPr txBox="1"/>
+          <p:nvPr/>
+        </p:nvSpPr>
+        <p:spPr>
+          <a:xfrm>
+            <a:off x="457200" y="6400800"/>
+            <a:ext cx="12070080" cy="1463040"/>
+          </a:xfrm>
+          <a:prstGeom prst="rect">
+            <a:avLst/>
+          </a:prstGeom>
+          <a:noFill/>
+          <a:ln/>
+        </p:spPr>
+        <p:txBody>
+          <a:bodyPr wrap="square" lIns="0" tIns="0" rIns="0" bIns="0" rtlCol="0" anchor="t"/>
+          <a:lstStyle/>
+          <a:p>
+            <a:pPr indent="0" marL="0">
+              <a:buNone/>
+            </a:pPr>
+            <a:r>
+              <a:rPr lang="en-US" sz="2000" dirty="0">
                 <a:solidFill>
                   <a:srgbClr val="1F1F1F"/>
                 </a:solidFill>
@@ -28914,120 +28484,15 @@
                 <a:ea typeface="Helvetica Neue Light" pitchFamily="34" charset="-122"/>
                 <a:cs typeface="Helvetica Neue Light" pitchFamily="34" charset="-120"/>
               </a:rPr>
-              <a:t>Validate the three personas with five to eight interviews</a:t>
-            </a:r>
-            <a:endParaRPr lang="en-US" sz="1800" dirty="0"/>
-          </a:p>
-          <a:p>
-            <a:pPr marL="203200" indent="-203200">
-              <a:spcAft>
-                <a:spcPts val="600"/>
-              </a:spcAft>
-              <a:buSzPct val="100000"/>
-              <a:buChar char="•"/>
-            </a:pPr>
-            <a:r>
-              <a:rPr lang="en-US" sz="1800" dirty="0">
-                <a:solidFill>
-                  <a:srgbClr val="1F1F1F"/>
-                </a:solidFill>
-                <a:latin typeface="Helvetica Neue Light" pitchFamily="34" charset="0"/>
-                <a:ea typeface="Helvetica Neue Light" pitchFamily="34" charset="-122"/>
-                <a:cs typeface="Helvetica Neue Light" pitchFamily="34" charset="-120"/>
-              </a:rPr>
-              <a:t>Usability-test the share and dollar flows</a:t>
-            </a:r>
-            <a:endParaRPr lang="en-US" sz="1800" dirty="0"/>
-          </a:p>
-          <a:p>
-            <a:pPr marL="203200" indent="-203200">
-              <a:spcAft>
-                <a:spcPts val="600"/>
-              </a:spcAft>
-              <a:buSzPct val="100000"/>
-              <a:buChar char="•"/>
-            </a:pPr>
-            <a:r>
-              <a:rPr lang="en-US" sz="1800" dirty="0">
-                <a:solidFill>
-                  <a:srgbClr val="1F1F1F"/>
-                </a:solidFill>
-                <a:latin typeface="Helvetica Neue Light" pitchFamily="34" charset="0"/>
-                <a:ea typeface="Helvetica Neue Light" pitchFamily="34" charset="-122"/>
-                <a:cs typeface="Helvetica Neue Light" pitchFamily="34" charset="-120"/>
-              </a:rPr>
-              <a:t>Review the 20 wireframe states with stakeholders</a:t>
-            </a:r>
-            <a:endParaRPr lang="en-US" sz="1800" dirty="0"/>
-          </a:p>
-          <a:p>
-            <a:pPr marL="203200" indent="-203200">
-              <a:spcAft>
-                <a:spcPts val="600"/>
-              </a:spcAft>
-              <a:buSzPct val="100000"/>
-              <a:buChar char="•"/>
-            </a:pPr>
-            <a:r>
-              <a:rPr lang="en-US" sz="1800" dirty="0">
-                <a:solidFill>
-                  <a:srgbClr val="1F1F1F"/>
-                </a:solidFill>
-                <a:latin typeface="Helvetica Neue Light" pitchFamily="34" charset="0"/>
-                <a:ea typeface="Helvetica Neue Light" pitchFamily="34" charset="-122"/>
-                <a:cs typeface="Helvetica Neue Light" pitchFamily="34" charset="-120"/>
-              </a:rPr>
-              <a:t>Resolve the open questions on the FigJam board</a:t>
-            </a:r>
-            <a:endParaRPr lang="en-US" sz="1800" dirty="0"/>
-          </a:p>
-          <a:p>
-            <a:pPr marL="203200" indent="-203200">
-              <a:spcAft>
-                <a:spcPts val="600"/>
-              </a:spcAft>
-              <a:buSzPct val="100000"/>
-              <a:buChar char="•"/>
-            </a:pPr>
-            <a:r>
-              <a:rPr lang="en-US" sz="1800" dirty="0">
-                <a:solidFill>
-                  <a:srgbClr val="1F1F1F"/>
-                </a:solidFill>
-                <a:latin typeface="Helvetica Neue Light" pitchFamily="34" charset="0"/>
-                <a:ea typeface="Helvetica Neue Light" pitchFamily="34" charset="-122"/>
-                <a:cs typeface="Helvetica Neue Light" pitchFamily="34" charset="-120"/>
-              </a:rPr>
-              <a:t>Set metric targets with stakeholders</a:t>
-            </a:r>
-            <a:endParaRPr lang="en-US" sz="1800" dirty="0"/>
-          </a:p>
-          <a:p>
-            <a:pPr marL="203200" indent="-203200">
-              <a:spcAft>
-                <a:spcPts val="600"/>
-              </a:spcAft>
-              <a:buSzPct val="100000"/>
-              <a:buChar char="•"/>
-            </a:pPr>
-            <a:r>
-              <a:rPr lang="en-US" sz="1800" dirty="0">
-                <a:solidFill>
-                  <a:srgbClr val="1F1F1F"/>
-                </a:solidFill>
-                <a:latin typeface="Helvetica Neue Light" pitchFamily="34" charset="0"/>
-                <a:ea typeface="Helvetica Neue Light" pitchFamily="34" charset="-122"/>
-                <a:cs typeface="Helvetica Neue Light" pitchFamily="34" charset="-120"/>
-              </a:rPr>
-              <a:t>Schedule the compliance review</a:t>
-            </a:r>
-            <a:endParaRPr lang="en-US" sz="1800" dirty="0"/>
+              <a:t>Time to complete a trade, task success, the share of users who open an AI screen in week one, and a usability score. Targets are planned and will be set with stakeholders before the first test.</a:t>
+            </a:r>
+            <a:endParaRPr lang="en-US" sz="2000" dirty="0"/>
           </a:p>
         </p:txBody>
       </p:sp>
       <p:pic>
         <p:nvPicPr>
-          <p:cNvPr id="20" name="Image 1" descr="/tmp/meridian-deck/img/band-footer.png">    </p:cNvPr>
+          <p:cNvPr id="19" name="Image 1" descr="/tmp/meridian-deck/img/band-footer.png">    </p:cNvPr>
           <p:cNvPicPr>
             <a:picLocks noChangeAspect="1"/>
           </p:cNvPicPr>
@@ -29058,6 +28523,795 @@
 </file>
 
 <file path=ppt/slides/slide48.xml><?xml version="1.0" encoding="utf-8"?>
+<p:sld xmlns:a="http://schemas.openxmlformats.org/drawingml/2006/main" xmlns:p="http://schemas.openxmlformats.org/presentationml/2006/main" xmlns:r="http://schemas.openxmlformats.org/officeDocument/2006/relationships">
+  <p:cSld>
+    <p:bg>
+      <p:bgPr>
+        <a:solidFill>
+          <a:srgbClr val="FFFFFF"/>
+        </a:solidFill>
+      </p:bgPr>
+    </p:bg>
+    <p:spTree>
+      <p:nvGrpSpPr>
+        <p:cNvPr id="1" name=""/>
+        <p:cNvGrpSpPr/>
+        <p:nvPr/>
+      </p:nvGrpSpPr>
+      <p:grpSpPr/>
+      <p:sp>
+        <p:nvSpPr>
+          <p:cNvPr id="2" name="Text 0"/>
+          <p:cNvSpPr txBox="1"/>
+          <p:nvPr/>
+        </p:nvSpPr>
+        <p:spPr>
+          <a:xfrm>
+            <a:off x="457200" y="393192"/>
+            <a:ext cx="10424160" cy="274320"/>
+          </a:xfrm>
+          <a:prstGeom prst="rect">
+            <a:avLst/>
+          </a:prstGeom>
+          <a:noFill/>
+          <a:ln/>
+        </p:spPr>
+        <p:txBody>
+          <a:bodyPr wrap="square" lIns="0" tIns="0" rIns="0" bIns="0" rtlCol="0" anchor="t"/>
+          <a:lstStyle/>
+          <a:p>
+            <a:pPr indent="0" marL="0">
+              <a:buNone/>
+            </a:pPr>
+            <a:r>
+              <a:rPr lang="en-US" sz="1422" dirty="0">
+                <a:solidFill>
+                  <a:srgbClr val="1F1F1F"/>
+                </a:solidFill>
+                <a:latin typeface="Helvetica Neue" pitchFamily="34" charset="0"/>
+                <a:ea typeface="Helvetica Neue" pitchFamily="34" charset="-122"/>
+                <a:cs typeface="Helvetica Neue" pitchFamily="34" charset="-120"/>
+              </a:rPr>
+              <a:t>10 · Learnings &amp; next steps   Meridian Navigator</a:t>
+            </a:r>
+            <a:endParaRPr lang="en-US" sz="1422" dirty="0"/>
+          </a:p>
+        </p:txBody>
+      </p:sp>
+      <p:sp>
+        <p:nvSpPr>
+          <p:cNvPr id="3" name="Text 1"/>
+          <p:cNvSpPr txBox="1"/>
+          <p:nvPr/>
+        </p:nvSpPr>
+        <p:spPr>
+          <a:xfrm>
+            <a:off x="457200" y="914400"/>
+            <a:ext cx="12070080" cy="594360"/>
+          </a:xfrm>
+          <a:prstGeom prst="rect">
+            <a:avLst/>
+          </a:prstGeom>
+          <a:noFill/>
+          <a:ln/>
+        </p:spPr>
+        <p:txBody>
+          <a:bodyPr wrap="square" lIns="0" tIns="0" rIns="0" bIns="0" rtlCol="0" anchor="t"/>
+          <a:lstStyle/>
+          <a:p>
+            <a:pPr indent="0" marL="0">
+              <a:buNone/>
+            </a:pPr>
+            <a:r>
+              <a:rPr lang="en-US" sz="3200" dirty="0">
+                <a:solidFill>
+                  <a:srgbClr val="1F1F1F"/>
+                </a:solidFill>
+                <a:latin typeface="Helvetica Neue Light" pitchFamily="34" charset="0"/>
+                <a:ea typeface="Helvetica Neue Light" pitchFamily="34" charset="-122"/>
+                <a:cs typeface="Helvetica Neue Light" pitchFamily="34" charset="-120"/>
+              </a:rPr>
+              <a:t>What building this taught me, and what comes next</a:t>
+            </a:r>
+            <a:endParaRPr lang="en-US" sz="3200" dirty="0"/>
+          </a:p>
+        </p:txBody>
+      </p:sp>
+      <p:pic>
+        <p:nvPicPr>
+          <p:cNvPr id="4" name="Image 0" descr="/tmp/meridian-deck/img/band-footer.png">    </p:cNvPr>
+          <p:cNvPicPr>
+            <a:picLocks noChangeAspect="1"/>
+          </p:cNvPicPr>
+          <p:nvPr/>
+        </p:nvPicPr>
+        <p:blipFill>
+          <a:blip r:embed="rId2"/>
+          <a:stretch>
+            <a:fillRect/>
+          </a:stretch>
+        </p:blipFill>
+        <p:spPr>
+          <a:xfrm>
+            <a:off x="0" y="9281160"/>
+            <a:ext cx="13004597" cy="466344"/>
+          </a:xfrm>
+          <a:prstGeom prst="rect">
+            <a:avLst/>
+          </a:prstGeom>
+        </p:spPr>
+      </p:pic>
+      <p:sp>
+        <p:nvSpPr>
+          <p:cNvPr id="5" name="Text 2"/>
+          <p:cNvSpPr txBox="1"/>
+          <p:nvPr/>
+        </p:nvSpPr>
+        <p:spPr>
+          <a:xfrm>
+            <a:off x="457200" y="2468880"/>
+            <a:ext cx="5669280" cy="274320"/>
+          </a:xfrm>
+          <a:prstGeom prst="rect">
+            <a:avLst/>
+          </a:prstGeom>
+          <a:noFill/>
+          <a:ln/>
+        </p:spPr>
+        <p:txBody>
+          <a:bodyPr wrap="square" lIns="0" tIns="0" rIns="0" bIns="0" rtlCol="0" anchor="t"/>
+          <a:lstStyle/>
+          <a:p>
+            <a:pPr indent="0" marL="0">
+              <a:buNone/>
+            </a:pPr>
+            <a:r>
+              <a:rPr lang="en-US" sz="1280" spc="100" kern="0" dirty="0">
+                <a:solidFill>
+                  <a:srgbClr val="C45A35"/>
+                </a:solidFill>
+                <a:latin typeface="Helvetica Neue" pitchFamily="34" charset="0"/>
+                <a:ea typeface="Helvetica Neue" pitchFamily="34" charset="-122"/>
+                <a:cs typeface="Helvetica Neue" pitchFamily="34" charset="-120"/>
+              </a:rPr>
+              <a:t>LEARNINGS</a:t>
+            </a:r>
+            <a:endParaRPr lang="en-US" sz="1280" dirty="0"/>
+          </a:p>
+        </p:txBody>
+      </p:sp>
+      <p:sp>
+        <p:nvSpPr>
+          <p:cNvPr id="6" name="Shape 3"/>
+          <p:cNvSpPr/>
+          <p:nvPr/>
+        </p:nvSpPr>
+        <p:spPr>
+          <a:xfrm>
+            <a:off x="457200" y="3017520"/>
+            <a:ext cx="420624" cy="420624"/>
+          </a:xfrm>
+          <a:prstGeom prst="ellipse">
+            <a:avLst/>
+          </a:prstGeom>
+          <a:solidFill>
+            <a:srgbClr val="C45A35"/>
+          </a:solidFill>
+          <a:ln w="12700">
+            <a:solidFill>
+              <a:srgbClr val="C45A35"/>
+            </a:solidFill>
+            <a:prstDash val="solid"/>
+          </a:ln>
+        </p:spPr>
+      </p:sp>
+      <p:sp>
+        <p:nvSpPr>
+          <p:cNvPr id="7" name="Text 4"/>
+          <p:cNvSpPr txBox="1"/>
+          <p:nvPr/>
+        </p:nvSpPr>
+        <p:spPr>
+          <a:xfrm>
+            <a:off x="457200" y="3081528"/>
+            <a:ext cx="420624" cy="292608"/>
+          </a:xfrm>
+          <a:prstGeom prst="rect">
+            <a:avLst/>
+          </a:prstGeom>
+          <a:noFill/>
+          <a:ln/>
+        </p:spPr>
+        <p:txBody>
+          <a:bodyPr wrap="square" lIns="0" tIns="0" rIns="0" bIns="0" rtlCol="0" anchor="t"/>
+          <a:lstStyle/>
+          <a:p>
+            <a:pPr algn="ctr" indent="0" marL="0">
+              <a:buNone/>
+            </a:pPr>
+            <a:r>
+              <a:rPr lang="en-US" sz="1564" b="1" dirty="0">
+                <a:solidFill>
+                  <a:srgbClr val="FFFFFF"/>
+                </a:solidFill>
+                <a:latin typeface="Helvetica Neue" pitchFamily="34" charset="0"/>
+                <a:ea typeface="Helvetica Neue" pitchFamily="34" charset="-122"/>
+                <a:cs typeface="Helvetica Neue" pitchFamily="34" charset="-120"/>
+              </a:rPr>
+              <a:t>1</a:t>
+            </a:r>
+            <a:endParaRPr lang="en-US" sz="1564" dirty="0"/>
+          </a:p>
+        </p:txBody>
+      </p:sp>
+      <p:sp>
+        <p:nvSpPr>
+          <p:cNvPr id="8" name="Text 5"/>
+          <p:cNvSpPr txBox="1"/>
+          <p:nvPr/>
+        </p:nvSpPr>
+        <p:spPr>
+          <a:xfrm>
+            <a:off x="1097280" y="3035808"/>
+            <a:ext cx="5120640" cy="1097280"/>
+          </a:xfrm>
+          <a:prstGeom prst="rect">
+            <a:avLst/>
+          </a:prstGeom>
+          <a:noFill/>
+          <a:ln/>
+        </p:spPr>
+        <p:txBody>
+          <a:bodyPr wrap="square" lIns="0" tIns="0" rIns="0" bIns="0" rtlCol="0" anchor="t"/>
+          <a:lstStyle/>
+          <a:p>
+            <a:pPr indent="0" marL="0">
+              <a:buNone/>
+            </a:pPr>
+            <a:r>
+              <a:rPr lang="en-US" sz="1800" dirty="0">
+                <a:solidFill>
+                  <a:srgbClr val="1F1F1F"/>
+                </a:solidFill>
+                <a:latin typeface="Helvetica Neue Light" pitchFamily="34" charset="0"/>
+                <a:ea typeface="Helvetica Neue Light" pitchFamily="34" charset="-122"/>
+                <a:cs typeface="Helvetica Neue Light" pitchFamily="34" charset="-120"/>
+              </a:rPr>
+              <a:t>One token source for Figma and Swift keeps the two in step.</a:t>
+            </a:r>
+            <a:endParaRPr lang="en-US" sz="1800" dirty="0"/>
+          </a:p>
+        </p:txBody>
+      </p:sp>
+      <p:sp>
+        <p:nvSpPr>
+          <p:cNvPr id="9" name="Shape 6"/>
+          <p:cNvSpPr/>
+          <p:nvPr/>
+        </p:nvSpPr>
+        <p:spPr>
+          <a:xfrm>
+            <a:off x="457200" y="4389120"/>
+            <a:ext cx="420624" cy="420624"/>
+          </a:xfrm>
+          <a:prstGeom prst="ellipse">
+            <a:avLst/>
+          </a:prstGeom>
+          <a:solidFill>
+            <a:srgbClr val="C45A35"/>
+          </a:solidFill>
+          <a:ln w="12700">
+            <a:solidFill>
+              <a:srgbClr val="C45A35"/>
+            </a:solidFill>
+            <a:prstDash val="solid"/>
+          </a:ln>
+        </p:spPr>
+      </p:sp>
+      <p:sp>
+        <p:nvSpPr>
+          <p:cNvPr id="10" name="Text 7"/>
+          <p:cNvSpPr txBox="1"/>
+          <p:nvPr/>
+        </p:nvSpPr>
+        <p:spPr>
+          <a:xfrm>
+            <a:off x="457200" y="4453128"/>
+            <a:ext cx="420624" cy="292608"/>
+          </a:xfrm>
+          <a:prstGeom prst="rect">
+            <a:avLst/>
+          </a:prstGeom>
+          <a:noFill/>
+          <a:ln/>
+        </p:spPr>
+        <p:txBody>
+          <a:bodyPr wrap="square" lIns="0" tIns="0" rIns="0" bIns="0" rtlCol="0" anchor="t"/>
+          <a:lstStyle/>
+          <a:p>
+            <a:pPr algn="ctr" indent="0" marL="0">
+              <a:buNone/>
+            </a:pPr>
+            <a:r>
+              <a:rPr lang="en-US" sz="1564" b="1" dirty="0">
+                <a:solidFill>
+                  <a:srgbClr val="FFFFFF"/>
+                </a:solidFill>
+                <a:latin typeface="Helvetica Neue" pitchFamily="34" charset="0"/>
+                <a:ea typeface="Helvetica Neue" pitchFamily="34" charset="-122"/>
+                <a:cs typeface="Helvetica Neue" pitchFamily="34" charset="-120"/>
+              </a:rPr>
+              <a:t>2</a:t>
+            </a:r>
+            <a:endParaRPr lang="en-US" sz="1564" dirty="0"/>
+          </a:p>
+        </p:txBody>
+      </p:sp>
+      <p:sp>
+        <p:nvSpPr>
+          <p:cNvPr id="11" name="Text 8"/>
+          <p:cNvSpPr txBox="1"/>
+          <p:nvPr/>
+        </p:nvSpPr>
+        <p:spPr>
+          <a:xfrm>
+            <a:off x="1097280" y="4407408"/>
+            <a:ext cx="5120640" cy="1097280"/>
+          </a:xfrm>
+          <a:prstGeom prst="rect">
+            <a:avLst/>
+          </a:prstGeom>
+          <a:noFill/>
+          <a:ln/>
+        </p:spPr>
+        <p:txBody>
+          <a:bodyPr wrap="square" lIns="0" tIns="0" rIns="0" bIns="0" rtlCol="0" anchor="t"/>
+          <a:lstStyle/>
+          <a:p>
+            <a:pPr indent="0" marL="0">
+              <a:buNone/>
+            </a:pPr>
+            <a:r>
+              <a:rPr lang="en-US" sz="1800" dirty="0">
+                <a:solidFill>
+                  <a:srgbClr val="1F1F1F"/>
+                </a:solidFill>
+                <a:latin typeface="Helvetica Neue Light" pitchFamily="34" charset="0"/>
+                <a:ea typeface="Helvetica Neue Light" pitchFamily="34" charset="-122"/>
+                <a:cs typeface="Helvetica Neue Light" pitchFamily="34" charset="-120"/>
+              </a:rPr>
+              <a:t>Settle AI boundaries before more screens. Adapt’s buy and sell wording needs compliance first.</a:t>
+            </a:r>
+            <a:endParaRPr lang="en-US" sz="1800" dirty="0"/>
+          </a:p>
+        </p:txBody>
+      </p:sp>
+      <p:sp>
+        <p:nvSpPr>
+          <p:cNvPr id="12" name="Shape 9"/>
+          <p:cNvSpPr/>
+          <p:nvPr/>
+        </p:nvSpPr>
+        <p:spPr>
+          <a:xfrm>
+            <a:off x="457200" y="5760720"/>
+            <a:ext cx="420624" cy="420624"/>
+          </a:xfrm>
+          <a:prstGeom prst="ellipse">
+            <a:avLst/>
+          </a:prstGeom>
+          <a:solidFill>
+            <a:srgbClr val="C45A35"/>
+          </a:solidFill>
+          <a:ln w="12700">
+            <a:solidFill>
+              <a:srgbClr val="C45A35"/>
+            </a:solidFill>
+            <a:prstDash val="solid"/>
+          </a:ln>
+        </p:spPr>
+      </p:sp>
+      <p:sp>
+        <p:nvSpPr>
+          <p:cNvPr id="13" name="Text 10"/>
+          <p:cNvSpPr txBox="1"/>
+          <p:nvPr/>
+        </p:nvSpPr>
+        <p:spPr>
+          <a:xfrm>
+            <a:off x="457200" y="5824728"/>
+            <a:ext cx="420624" cy="292608"/>
+          </a:xfrm>
+          <a:prstGeom prst="rect">
+            <a:avLst/>
+          </a:prstGeom>
+          <a:noFill/>
+          <a:ln/>
+        </p:spPr>
+        <p:txBody>
+          <a:bodyPr wrap="square" lIns="0" tIns="0" rIns="0" bIns="0" rtlCol="0" anchor="t"/>
+          <a:lstStyle/>
+          <a:p>
+            <a:pPr algn="ctr" indent="0" marL="0">
+              <a:buNone/>
+            </a:pPr>
+            <a:r>
+              <a:rPr lang="en-US" sz="1564" b="1" dirty="0">
+                <a:solidFill>
+                  <a:srgbClr val="FFFFFF"/>
+                </a:solidFill>
+                <a:latin typeface="Helvetica Neue" pitchFamily="34" charset="0"/>
+                <a:ea typeface="Helvetica Neue" pitchFamily="34" charset="-122"/>
+                <a:cs typeface="Helvetica Neue" pitchFamily="34" charset="-120"/>
+              </a:rPr>
+              <a:t>3</a:t>
+            </a:r>
+            <a:endParaRPr lang="en-US" sz="1564" dirty="0"/>
+          </a:p>
+        </p:txBody>
+      </p:sp>
+      <p:sp>
+        <p:nvSpPr>
+          <p:cNvPr id="14" name="Text 11"/>
+          <p:cNvSpPr txBox="1"/>
+          <p:nvPr/>
+        </p:nvSpPr>
+        <p:spPr>
+          <a:xfrm>
+            <a:off x="1097280" y="5779008"/>
+            <a:ext cx="5120640" cy="1097280"/>
+          </a:xfrm>
+          <a:prstGeom prst="rect">
+            <a:avLst/>
+          </a:prstGeom>
+          <a:noFill/>
+          <a:ln/>
+        </p:spPr>
+        <p:txBody>
+          <a:bodyPr wrap="square" lIns="0" tIns="0" rIns="0" bIns="0" rtlCol="0" anchor="t"/>
+          <a:lstStyle/>
+          <a:p>
+            <a:pPr indent="0" marL="0">
+              <a:buNone/>
+            </a:pPr>
+            <a:r>
+              <a:rPr lang="en-US" sz="1800" dirty="0">
+                <a:solidFill>
+                  <a:srgbClr val="1F1F1F"/>
+                </a:solidFill>
+                <a:latin typeface="Helvetica Neue Light" pitchFamily="34" charset="0"/>
+                <a:ea typeface="Helvetica Neue Light" pitchFamily="34" charset="-122"/>
+                <a:cs typeface="Helvetica Neue Light" pitchFamily="34" charset="-120"/>
+              </a:rPr>
+              <a:t>Mock data hides timing and error states, so design them explicitly.</a:t>
+            </a:r>
+            <a:endParaRPr lang="en-US" sz="1800" dirty="0"/>
+          </a:p>
+        </p:txBody>
+      </p:sp>
+      <p:sp>
+        <p:nvSpPr>
+          <p:cNvPr id="15" name="Shape 12"/>
+          <p:cNvSpPr/>
+          <p:nvPr/>
+        </p:nvSpPr>
+        <p:spPr>
+          <a:xfrm>
+            <a:off x="457200" y="7132320"/>
+            <a:ext cx="420624" cy="420624"/>
+          </a:xfrm>
+          <a:prstGeom prst="ellipse">
+            <a:avLst/>
+          </a:prstGeom>
+          <a:solidFill>
+            <a:srgbClr val="C45A35"/>
+          </a:solidFill>
+          <a:ln w="12700">
+            <a:solidFill>
+              <a:srgbClr val="C45A35"/>
+            </a:solidFill>
+            <a:prstDash val="solid"/>
+          </a:ln>
+        </p:spPr>
+      </p:sp>
+      <p:sp>
+        <p:nvSpPr>
+          <p:cNvPr id="16" name="Text 13"/>
+          <p:cNvSpPr txBox="1"/>
+          <p:nvPr/>
+        </p:nvSpPr>
+        <p:spPr>
+          <a:xfrm>
+            <a:off x="457200" y="7196328"/>
+            <a:ext cx="420624" cy="292608"/>
+          </a:xfrm>
+          <a:prstGeom prst="rect">
+            <a:avLst/>
+          </a:prstGeom>
+          <a:noFill/>
+          <a:ln/>
+        </p:spPr>
+        <p:txBody>
+          <a:bodyPr wrap="square" lIns="0" tIns="0" rIns="0" bIns="0" rtlCol="0" anchor="t"/>
+          <a:lstStyle/>
+          <a:p>
+            <a:pPr algn="ctr" indent="0" marL="0">
+              <a:buNone/>
+            </a:pPr>
+            <a:r>
+              <a:rPr lang="en-US" sz="1564" b="1" dirty="0">
+                <a:solidFill>
+                  <a:srgbClr val="FFFFFF"/>
+                </a:solidFill>
+                <a:latin typeface="Helvetica Neue" pitchFamily="34" charset="0"/>
+                <a:ea typeface="Helvetica Neue" pitchFamily="34" charset="-122"/>
+                <a:cs typeface="Helvetica Neue" pitchFamily="34" charset="-120"/>
+              </a:rPr>
+              <a:t>4</a:t>
+            </a:r>
+            <a:endParaRPr lang="en-US" sz="1564" dirty="0"/>
+          </a:p>
+        </p:txBody>
+      </p:sp>
+      <p:sp>
+        <p:nvSpPr>
+          <p:cNvPr id="17" name="Text 14"/>
+          <p:cNvSpPr txBox="1"/>
+          <p:nvPr/>
+        </p:nvSpPr>
+        <p:spPr>
+          <a:xfrm>
+            <a:off x="1097280" y="7150608"/>
+            <a:ext cx="5120640" cy="1097280"/>
+          </a:xfrm>
+          <a:prstGeom prst="rect">
+            <a:avLst/>
+          </a:prstGeom>
+          <a:noFill/>
+          <a:ln/>
+        </p:spPr>
+        <p:txBody>
+          <a:bodyPr wrap="square" lIns="0" tIns="0" rIns="0" bIns="0" rtlCol="0" anchor="t"/>
+          <a:lstStyle/>
+          <a:p>
+            <a:pPr indent="0" marL="0">
+              <a:buNone/>
+            </a:pPr>
+            <a:r>
+              <a:rPr lang="en-US" sz="1800" dirty="0">
+                <a:solidFill>
+                  <a:srgbClr val="1F1F1F"/>
+                </a:solidFill>
+                <a:latin typeface="Helvetica Neue Light" pitchFamily="34" charset="0"/>
+                <a:ea typeface="Helvetica Neue Light" pitchFamily="34" charset="-122"/>
+                <a:cs typeface="Helvetica Neue Light" pitchFamily="34" charset="-120"/>
+              </a:rPr>
+              <a:t>Keep working documents in one place: the FigJam board.</a:t>
+            </a:r>
+            <a:endParaRPr lang="en-US" sz="1800" dirty="0"/>
+          </a:p>
+        </p:txBody>
+      </p:sp>
+      <p:sp>
+        <p:nvSpPr>
+          <p:cNvPr id="18" name="Text 15"/>
+          <p:cNvSpPr txBox="1"/>
+          <p:nvPr/>
+        </p:nvSpPr>
+        <p:spPr>
+          <a:xfrm>
+            <a:off x="6583680" y="2468880"/>
+            <a:ext cx="5669280" cy="274320"/>
+          </a:xfrm>
+          <a:prstGeom prst="rect">
+            <a:avLst/>
+          </a:prstGeom>
+          <a:noFill/>
+          <a:ln/>
+        </p:spPr>
+        <p:txBody>
+          <a:bodyPr wrap="square" lIns="0" tIns="0" rIns="0" bIns="0" rtlCol="0" anchor="t"/>
+          <a:lstStyle/>
+          <a:p>
+            <a:pPr indent="0" marL="0">
+              <a:buNone/>
+            </a:pPr>
+            <a:r>
+              <a:rPr lang="en-US" sz="1280" spc="100" kern="0" dirty="0">
+                <a:solidFill>
+                  <a:srgbClr val="5B3F96"/>
+                </a:solidFill>
+                <a:latin typeface="Helvetica Neue" pitchFamily="34" charset="0"/>
+                <a:ea typeface="Helvetica Neue" pitchFamily="34" charset="-122"/>
+                <a:cs typeface="Helvetica Neue" pitchFamily="34" charset="-120"/>
+              </a:rPr>
+              <a:t>NEXT STEPS</a:t>
+            </a:r>
+            <a:endParaRPr lang="en-US" sz="1280" dirty="0"/>
+          </a:p>
+        </p:txBody>
+      </p:sp>
+      <p:sp>
+        <p:nvSpPr>
+          <p:cNvPr id="19" name="Text 16"/>
+          <p:cNvSpPr txBox="1"/>
+          <p:nvPr/>
+        </p:nvSpPr>
+        <p:spPr>
+          <a:xfrm>
+            <a:off x="6583680" y="3017520"/>
+            <a:ext cx="5669280" cy="5029200"/>
+          </a:xfrm>
+          <a:prstGeom prst="rect">
+            <a:avLst/>
+          </a:prstGeom>
+          <a:noFill/>
+          <a:ln/>
+        </p:spPr>
+        <p:txBody>
+          <a:bodyPr wrap="square" lIns="0" tIns="0" rIns="0" bIns="0" rtlCol="0" anchor="t"/>
+          <a:lstStyle/>
+          <a:p>
+            <a:pPr marL="203200" indent="-203200">
+              <a:spcAft>
+                <a:spcPts val="600"/>
+              </a:spcAft>
+              <a:buSzPct val="100000"/>
+              <a:buChar char="•"/>
+            </a:pPr>
+            <a:r>
+              <a:rPr lang="en-US" sz="1800" dirty="0">
+                <a:solidFill>
+                  <a:srgbClr val="1F1F1F"/>
+                </a:solidFill>
+                <a:latin typeface="Helvetica Neue Light" pitchFamily="34" charset="0"/>
+                <a:ea typeface="Helvetica Neue Light" pitchFamily="34" charset="-122"/>
+                <a:cs typeface="Helvetica Neue Light" pitchFamily="34" charset="-120"/>
+              </a:rPr>
+              <a:t>Validate the three personas with five to eight interviews</a:t>
+            </a:r>
+            <a:endParaRPr lang="en-US" sz="1800" dirty="0"/>
+          </a:p>
+          <a:p>
+            <a:pPr marL="203200" indent="-203200">
+              <a:spcAft>
+                <a:spcPts val="600"/>
+              </a:spcAft>
+              <a:buSzPct val="100000"/>
+              <a:buChar char="•"/>
+            </a:pPr>
+            <a:r>
+              <a:rPr lang="en-US" sz="1800" dirty="0">
+                <a:solidFill>
+                  <a:srgbClr val="1F1F1F"/>
+                </a:solidFill>
+                <a:latin typeface="Helvetica Neue Light" pitchFamily="34" charset="0"/>
+                <a:ea typeface="Helvetica Neue Light" pitchFamily="34" charset="-122"/>
+                <a:cs typeface="Helvetica Neue Light" pitchFamily="34" charset="-120"/>
+              </a:rPr>
+              <a:t>Usability-test the share and dollar flows</a:t>
+            </a:r>
+            <a:endParaRPr lang="en-US" sz="1800" dirty="0"/>
+          </a:p>
+          <a:p>
+            <a:pPr marL="203200" indent="-203200">
+              <a:spcAft>
+                <a:spcPts val="600"/>
+              </a:spcAft>
+              <a:buSzPct val="100000"/>
+              <a:buChar char="•"/>
+            </a:pPr>
+            <a:r>
+              <a:rPr lang="en-US" sz="1800" dirty="0">
+                <a:solidFill>
+                  <a:srgbClr val="1F1F1F"/>
+                </a:solidFill>
+                <a:latin typeface="Helvetica Neue Light" pitchFamily="34" charset="0"/>
+                <a:ea typeface="Helvetica Neue Light" pitchFamily="34" charset="-122"/>
+                <a:cs typeface="Helvetica Neue Light" pitchFamily="34" charset="-120"/>
+              </a:rPr>
+              <a:t>Review the 20 wireframe states with stakeholders</a:t>
+            </a:r>
+            <a:endParaRPr lang="en-US" sz="1800" dirty="0"/>
+          </a:p>
+          <a:p>
+            <a:pPr marL="203200" indent="-203200">
+              <a:spcAft>
+                <a:spcPts val="600"/>
+              </a:spcAft>
+              <a:buSzPct val="100000"/>
+              <a:buChar char="•"/>
+            </a:pPr>
+            <a:r>
+              <a:rPr lang="en-US" sz="1800" dirty="0">
+                <a:solidFill>
+                  <a:srgbClr val="1F1F1F"/>
+                </a:solidFill>
+                <a:latin typeface="Helvetica Neue Light" pitchFamily="34" charset="0"/>
+                <a:ea typeface="Helvetica Neue Light" pitchFamily="34" charset="-122"/>
+                <a:cs typeface="Helvetica Neue Light" pitchFamily="34" charset="-120"/>
+              </a:rPr>
+              <a:t>Resolve the open questions on the FigJam board</a:t>
+            </a:r>
+            <a:endParaRPr lang="en-US" sz="1800" dirty="0"/>
+          </a:p>
+          <a:p>
+            <a:pPr marL="203200" indent="-203200">
+              <a:spcAft>
+                <a:spcPts val="600"/>
+              </a:spcAft>
+              <a:buSzPct val="100000"/>
+              <a:buChar char="•"/>
+            </a:pPr>
+            <a:r>
+              <a:rPr lang="en-US" sz="1800" dirty="0">
+                <a:solidFill>
+                  <a:srgbClr val="1F1F1F"/>
+                </a:solidFill>
+                <a:latin typeface="Helvetica Neue Light" pitchFamily="34" charset="0"/>
+                <a:ea typeface="Helvetica Neue Light" pitchFamily="34" charset="-122"/>
+                <a:cs typeface="Helvetica Neue Light" pitchFamily="34" charset="-120"/>
+              </a:rPr>
+              <a:t>Set metric targets with stakeholders</a:t>
+            </a:r>
+            <a:endParaRPr lang="en-US" sz="1800" dirty="0"/>
+          </a:p>
+          <a:p>
+            <a:pPr marL="203200" indent="-203200">
+              <a:spcAft>
+                <a:spcPts val="600"/>
+              </a:spcAft>
+              <a:buSzPct val="100000"/>
+              <a:buChar char="•"/>
+            </a:pPr>
+            <a:r>
+              <a:rPr lang="en-US" sz="1800" dirty="0">
+                <a:solidFill>
+                  <a:srgbClr val="1F1F1F"/>
+                </a:solidFill>
+                <a:latin typeface="Helvetica Neue Light" pitchFamily="34" charset="0"/>
+                <a:ea typeface="Helvetica Neue Light" pitchFamily="34" charset="-122"/>
+                <a:cs typeface="Helvetica Neue Light" pitchFamily="34" charset="-120"/>
+              </a:rPr>
+              <a:t>Schedule the compliance review</a:t>
+            </a:r>
+            <a:endParaRPr lang="en-US" sz="1800" dirty="0"/>
+          </a:p>
+        </p:txBody>
+      </p:sp>
+      <p:pic>
+        <p:nvPicPr>
+          <p:cNvPr id="20" name="Image 1" descr="/tmp/meridian-deck/img/band-footer.png">    </p:cNvPr>
+          <p:cNvPicPr>
+            <a:picLocks noChangeAspect="1"/>
+          </p:cNvPicPr>
+          <p:nvPr/>
+        </p:nvPicPr>
+        <p:blipFill>
+          <a:blip r:embed="rId2"/>
+          <a:stretch>
+            <a:fillRect/>
+          </a:stretch>
+        </p:blipFill>
+        <p:spPr>
+          <a:xfrm>
+            <a:off x="0" y="9281160"/>
+            <a:ext cx="13004597" cy="466344"/>
+          </a:xfrm>
+          <a:prstGeom prst="rect">
+            <a:avLst/>
+          </a:prstGeom>
+        </p:spPr>
+      </p:pic>
+    </p:spTree>
+  </p:cSld>
+  <p:clrMapOvr>
+    <a:masterClrMapping/>
+  </p:clrMapOvr>
+</p:sld>
+</file>
+
+<file path=ppt/slides/slide49.xml><?xml version="1.0" encoding="utf-8"?>
 <p:sld xmlns:a="http://schemas.openxmlformats.org/drawingml/2006/main" xmlns:p="http://schemas.openxmlformats.org/presentationml/2006/main" xmlns:r="http://schemas.openxmlformats.org/officeDocument/2006/relationships">
   <p:cSld>
     <p:bg>

</xml_diff>

<commit_message>
Update portfolio decks with Meridian wireframe and next-step changes
Rebuild the complete (188), combined (144), and core (49) decks with the updated
Meridian deck.

Co-Authored-By: Claude Haiku 5.5 <noreply@anthropic.com>
</commit_message>
<xml_diff>
--- a/Portfolio-Core.pptx
+++ b/Portfolio-Core.pptx
@@ -15562,7 +15562,7 @@
                 <a:ea typeface="Helvetica Neue Light" pitchFamily="34" charset="-122"/>
                 <a:cs typeface="Helvetica Neue Light" pitchFamily="34" charset="-120"/>
               </a:rPr>
-              <a:t>Empty, loading, error and offline states on 06- Wireframes.</a:t>
+              <a:t>Empty, loading, error and offline states on 06- Wireframes. Agent flows on 07-, full experience on 08-.</a:t>
             </a:r>
             <a:endParaRPr lang="en-US" sz="1500" dirty="0"/>
           </a:p>
@@ -28367,7 +28367,7 @@
                 <a:ea typeface="Helvetica Neue" pitchFamily="34" charset="-122"/>
                 <a:cs typeface="Helvetica Neue" pitchFamily="34" charset="-120"/>
               </a:rPr>
-              <a:t>20</a:t>
+              <a:t>3</a:t>
             </a:r>
             <a:endParaRPr lang="en-US" sz="8000" dirty="0"/>
           </a:p>
@@ -28406,7 +28406,7 @@
                 <a:ea typeface="Helvetica Neue Light" pitchFamily="34" charset="-122"/>
                 <a:cs typeface="Helvetica Neue Light" pitchFamily="34" charset="-120"/>
               </a:rPr>
-              <a:t>hi-fi wireframe states on 06- Wireframes</a:t>
+              <a:t>wireframe pages: states, agent, and full experience (mock data)</a:t>
             </a:r>
             <a:endParaRPr lang="en-US" sz="1700" dirty="0"/>
           </a:p>
@@ -29210,7 +29210,7 @@
                 <a:ea typeface="Helvetica Neue Light" pitchFamily="34" charset="-122"/>
                 <a:cs typeface="Helvetica Neue Light" pitchFamily="34" charset="-120"/>
               </a:rPr>
-              <a:t>Review the 20 wireframe states with stakeholders</a:t>
+              <a:t>Review the three wireframe pages with stakeholders</a:t>
             </a:r>
             <a:endParaRPr lang="en-US" sz="1800" dirty="0"/>
           </a:p>
@@ -29273,7 +29273,7 @@
                 <a:ea typeface="Helvetica Neue Light" pitchFamily="34" charset="-122"/>
                 <a:cs typeface="Helvetica Neue Light" pitchFamily="34" charset="-120"/>
               </a:rPr>
-              <a:t>Schedule the compliance review</a:t>
+              <a:t>Replace Adapt buy and sell wording with proposed-step language, then schedule compliance review</a:t>
             </a:r>
             <a:endParaRPr lang="en-US" sz="1800" dirty="0"/>
           </a:p>

</xml_diff>